<commit_message>
008 FSM과 BT 최종(?)_gihyeon
</commit_message>
<xml_diff>
--- a/#presentations/006_FSM과 BT.pptx
+++ b/#presentations/006_FSM과 BT.pptx
@@ -11,11 +11,10 @@
     <p:sldId id="257" r:id="rId5"/>
     <p:sldId id="259" r:id="rId6"/>
     <p:sldId id="260" r:id="rId7"/>
-    <p:sldId id="261" r:id="rId8"/>
-    <p:sldId id="262" r:id="rId9"/>
-    <p:sldId id="263" r:id="rId10"/>
+    <p:sldId id="267" r:id="rId8"/>
+    <p:sldId id="263" r:id="rId9"/>
+    <p:sldId id="265" r:id="rId10"/>
     <p:sldId id="264" r:id="rId11"/>
-    <p:sldId id="265" r:id="rId12"/>
   </p:sldIdLst>
   <p:sldSz cx="12192000" cy="6858000"/>
   <p:notesSz cx="6858000" cy="9144000"/>
@@ -114,6 +113,11 @@
       </a:defRPr>
     </a:lvl9pPr>
   </p:defaultTextStyle>
+  <p:extLst>
+    <p:ext uri="{EFAFB233-063F-42B5-8137-9DF3F51BA10A}">
+      <p15:sldGuideLst xmlns:p15="http://schemas.microsoft.com/office/powerpoint/2012/main"/>
+    </p:ext>
+  </p:extLst>
 </p:presentation>
 </file>
 
@@ -264,7 +268,7 @@
           <a:p>
             <a:fld id="{1F014DE4-9230-49DC-B80E-862A2AF8FD4C}" type="datetimeFigureOut">
               <a:rPr lang="ko-KR" altLang="en-US" smtClean="0"/>
-              <a:t>2026-09-15</a:t>
+              <a:t>2026-09-29</a:t>
             </a:fld>
             <a:endParaRPr lang="ko-KR" altLang="en-US"/>
           </a:p>
@@ -462,7 +466,7 @@
           <a:p>
             <a:fld id="{1F014DE4-9230-49DC-B80E-862A2AF8FD4C}" type="datetimeFigureOut">
               <a:rPr lang="ko-KR" altLang="en-US" smtClean="0"/>
-              <a:t>2026-09-15</a:t>
+              <a:t>2026-09-29</a:t>
             </a:fld>
             <a:endParaRPr lang="ko-KR" altLang="en-US"/>
           </a:p>
@@ -670,7 +674,7 @@
           <a:p>
             <a:fld id="{1F014DE4-9230-49DC-B80E-862A2AF8FD4C}" type="datetimeFigureOut">
               <a:rPr lang="ko-KR" altLang="en-US" smtClean="0"/>
-              <a:t>2026-09-15</a:t>
+              <a:t>2026-09-29</a:t>
             </a:fld>
             <a:endParaRPr lang="ko-KR" altLang="en-US"/>
           </a:p>
@@ -868,7 +872,7 @@
           <a:p>
             <a:fld id="{1F014DE4-9230-49DC-B80E-862A2AF8FD4C}" type="datetimeFigureOut">
               <a:rPr lang="ko-KR" altLang="en-US" smtClean="0"/>
-              <a:t>2026-09-15</a:t>
+              <a:t>2026-09-29</a:t>
             </a:fld>
             <a:endParaRPr lang="ko-KR" altLang="en-US"/>
           </a:p>
@@ -1143,7 +1147,7 @@
           <a:p>
             <a:fld id="{1F014DE4-9230-49DC-B80E-862A2AF8FD4C}" type="datetimeFigureOut">
               <a:rPr lang="ko-KR" altLang="en-US" smtClean="0"/>
-              <a:t>2026-09-15</a:t>
+              <a:t>2026-09-29</a:t>
             </a:fld>
             <a:endParaRPr lang="ko-KR" altLang="en-US"/>
           </a:p>
@@ -1408,7 +1412,7 @@
           <a:p>
             <a:fld id="{1F014DE4-9230-49DC-B80E-862A2AF8FD4C}" type="datetimeFigureOut">
               <a:rPr lang="ko-KR" altLang="en-US" smtClean="0"/>
-              <a:t>2026-09-15</a:t>
+              <a:t>2026-09-29</a:t>
             </a:fld>
             <a:endParaRPr lang="ko-KR" altLang="en-US"/>
           </a:p>
@@ -1820,7 +1824,7 @@
           <a:p>
             <a:fld id="{1F014DE4-9230-49DC-B80E-862A2AF8FD4C}" type="datetimeFigureOut">
               <a:rPr lang="ko-KR" altLang="en-US" smtClean="0"/>
-              <a:t>2026-09-15</a:t>
+              <a:t>2026-09-29</a:t>
             </a:fld>
             <a:endParaRPr lang="ko-KR" altLang="en-US"/>
           </a:p>
@@ -1961,7 +1965,7 @@
           <a:p>
             <a:fld id="{1F014DE4-9230-49DC-B80E-862A2AF8FD4C}" type="datetimeFigureOut">
               <a:rPr lang="ko-KR" altLang="en-US" smtClean="0"/>
-              <a:t>2026-09-15</a:t>
+              <a:t>2026-09-29</a:t>
             </a:fld>
             <a:endParaRPr lang="ko-KR" altLang="en-US"/>
           </a:p>
@@ -2074,7 +2078,7 @@
           <a:p>
             <a:fld id="{1F014DE4-9230-49DC-B80E-862A2AF8FD4C}" type="datetimeFigureOut">
               <a:rPr lang="ko-KR" altLang="en-US" smtClean="0"/>
-              <a:t>2026-09-15</a:t>
+              <a:t>2026-09-29</a:t>
             </a:fld>
             <a:endParaRPr lang="ko-KR" altLang="en-US"/>
           </a:p>
@@ -2385,7 +2389,7 @@
           <a:p>
             <a:fld id="{1F014DE4-9230-49DC-B80E-862A2AF8FD4C}" type="datetimeFigureOut">
               <a:rPr lang="ko-KR" altLang="en-US" smtClean="0"/>
-              <a:t>2026-09-15</a:t>
+              <a:t>2026-09-29</a:t>
             </a:fld>
             <a:endParaRPr lang="ko-KR" altLang="en-US"/>
           </a:p>
@@ -2673,7 +2677,7 @@
           <a:p>
             <a:fld id="{1F014DE4-9230-49DC-B80E-862A2AF8FD4C}" type="datetimeFigureOut">
               <a:rPr lang="ko-KR" altLang="en-US" smtClean="0"/>
-              <a:t>2026-09-15</a:t>
+              <a:t>2026-09-29</a:t>
             </a:fld>
             <a:endParaRPr lang="ko-KR" altLang="en-US"/>
           </a:p>
@@ -2914,7 +2918,7 @@
           <a:p>
             <a:fld id="{1F014DE4-9230-49DC-B80E-862A2AF8FD4C}" type="datetimeFigureOut">
               <a:rPr lang="ko-KR" altLang="en-US" smtClean="0"/>
-              <a:t>2026-09-15</a:t>
+              <a:t>2026-09-29</a:t>
             </a:fld>
             <a:endParaRPr lang="ko-KR" altLang="en-US"/>
           </a:p>
@@ -3496,8 +3500,8 @@
         </p:nvSpPr>
         <p:spPr>
           <a:xfrm>
-            <a:off x="4231341" y="1816661"/>
-            <a:ext cx="5513294" cy="1417824"/>
+            <a:off x="3764032" y="1129240"/>
+            <a:ext cx="6832250" cy="1417824"/>
           </a:xfrm>
           <a:prstGeom prst="rect">
             <a:avLst/>
@@ -3548,6 +3552,18 @@
               <a:t>Combat</a:t>
             </a:r>
             <a:r>
+              <a:rPr lang="en-US" altLang="ko-KR" sz="2000" dirty="0"/>
+              <a:t>(</a:t>
+            </a:r>
+            <a:r>
+              <a:rPr lang="ko-KR" altLang="en-US" sz="2000" dirty="0"/>
+              <a:t>전투</a:t>
+            </a:r>
+            <a:r>
+              <a:rPr lang="en-US" altLang="ko-KR" sz="2000" dirty="0"/>
+              <a:t>)</a:t>
+            </a:r>
+            <a:r>
               <a:rPr lang="ko-KR" altLang="en-US" sz="2000" dirty="0"/>
               <a:t> 안에서 도망, 장전, 공격, 추적 같은 행동을 선택한다.</a:t>
             </a:r>
@@ -3568,7 +3584,7 @@
         </p:nvSpPr>
         <p:spPr>
           <a:xfrm>
-            <a:off x="4231341" y="3875787"/>
+            <a:off x="3874660" y="4465305"/>
             <a:ext cx="6364941" cy="1787349"/>
           </a:xfrm>
           <a:prstGeom prst="rect">
@@ -3604,8 +3620,9 @@
             </a:pPr>
             <a:r>
               <a:rPr lang="ko-KR" altLang="en-US" dirty="0"/>
-              <a:t>매 프레임 다시 선택되어도 괜찮은 행동</a:t>
-            </a:r>
+              <a:t>매 프레임 전이해야 하나 다시 검사하면 좋을 행동</a:t>
+            </a:r>
+            <a:endParaRPr lang="en-US" altLang="ko-KR" dirty="0"/>
           </a:p>
           <a:p>
             <a:pPr>
@@ -3673,399 +3690,134 @@
           </a:prstGeom>
         </p:spPr>
       </p:pic>
+      <p:sp>
+        <p:nvSpPr>
+          <p:cNvPr id="6" name="TextBox 5">
+            <a:extLst>
+              <a:ext uri="{FF2B5EF4-FFF2-40B4-BE49-F238E27FC236}">
+                <a16:creationId xmlns:a16="http://schemas.microsoft.com/office/drawing/2014/main" id="{C8C3EAEE-E7D6-4D9C-8943-1B13AEC3C694}"/>
+              </a:ext>
+            </a:extLst>
+          </p:cNvPr>
+          <p:cNvSpPr txBox="1"/>
+          <p:nvPr/>
+        </p:nvSpPr>
+        <p:spPr>
+          <a:xfrm>
+            <a:off x="3874660" y="2785634"/>
+            <a:ext cx="7422396" cy="1441100"/>
+          </a:xfrm>
+          <a:prstGeom prst="rect">
+            <a:avLst/>
+          </a:prstGeom>
+          <a:solidFill>
+            <a:schemeClr val="bg1">
+              <a:lumMod val="95000"/>
+            </a:schemeClr>
+          </a:solidFill>
+        </p:spPr>
+        <p:txBody>
+          <a:bodyPr wrap="square">
+            <a:spAutoFit/>
+          </a:bodyPr>
+          <a:lstStyle/>
+          <a:p>
+            <a:pPr>
+              <a:lnSpc>
+                <a:spcPct val="125000"/>
+              </a:lnSpc>
+            </a:pPr>
+            <a:r>
+              <a:rPr lang="ko-KR" altLang="en-US" dirty="0"/>
+              <a:t>만약 전투를</a:t>
+            </a:r>
+            <a:r>
+              <a:rPr lang="en-US" altLang="ko-KR" dirty="0"/>
+              <a:t> FSM</a:t>
+            </a:r>
+            <a:r>
+              <a:rPr lang="ko-KR" altLang="en-US" dirty="0"/>
+              <a:t>으로 넣으려면</a:t>
+            </a:r>
+            <a:r>
+              <a:rPr lang="en-US" altLang="ko-KR" dirty="0"/>
+              <a:t>, </a:t>
+            </a:r>
+            <a:r>
+              <a:rPr lang="ko-KR" altLang="en-US" dirty="0"/>
+              <a:t>각각의 상태 안에 </a:t>
+            </a:r>
+            <a:r>
+              <a:rPr lang="en-US" altLang="ko-KR" dirty="0"/>
+              <a:t>reload </a:t>
+            </a:r>
+            <a:r>
+              <a:rPr lang="ko-KR" altLang="en-US" dirty="0"/>
+              <a:t>할 건지 </a:t>
+            </a:r>
+            <a:r>
+              <a:rPr lang="en-US" altLang="ko-KR" dirty="0"/>
+              <a:t>attack </a:t>
+            </a:r>
+            <a:r>
+              <a:rPr lang="ko-KR" altLang="en-US" dirty="0"/>
+              <a:t>할 건지 </a:t>
+            </a:r>
+            <a:r>
+              <a:rPr lang="en-US" altLang="ko-KR" dirty="0"/>
+              <a:t>chase </a:t>
+            </a:r>
+            <a:r>
+              <a:rPr lang="ko-KR" altLang="en-US" dirty="0"/>
+              <a:t>할 건지 등을 따로 넣어줘야 함</a:t>
+            </a:r>
+            <a:r>
+              <a:rPr lang="en-US" altLang="ko-KR" dirty="0"/>
+              <a:t>.</a:t>
+            </a:r>
+          </a:p>
+          <a:p>
+            <a:pPr>
+              <a:lnSpc>
+                <a:spcPct val="125000"/>
+              </a:lnSpc>
+            </a:pPr>
+            <a:r>
+              <a:rPr lang="en-US" altLang="ko-KR" dirty="0"/>
+              <a:t>Flee </a:t>
+            </a:r>
+            <a:r>
+              <a:rPr lang="ko-KR" altLang="en-US" dirty="0"/>
+              <a:t>안에 </a:t>
+            </a:r>
+            <a:r>
+              <a:rPr lang="en-US" altLang="ko-KR" dirty="0"/>
+              <a:t>reload / attack / chase, reload</a:t>
+            </a:r>
+            <a:r>
+              <a:rPr lang="ko-KR" altLang="en-US" dirty="0"/>
+              <a:t> 안에 </a:t>
+            </a:r>
+            <a:r>
+              <a:rPr lang="en-US" altLang="ko-KR" dirty="0"/>
+              <a:t>attack / chase /search</a:t>
+            </a:r>
+            <a:r>
+              <a:rPr lang="ko-KR" altLang="en-US" dirty="0"/>
+              <a:t> 등등</a:t>
+            </a:r>
+            <a:r>
+              <a:rPr lang="en-US" altLang="ko-KR" dirty="0"/>
+              <a:t>..</a:t>
+            </a:r>
+            <a:endParaRPr lang="ko-KR" altLang="en-US" dirty="0"/>
+          </a:p>
+        </p:txBody>
+      </p:sp>
     </p:spTree>
     <p:extLst>
       <p:ext uri="{BB962C8B-B14F-4D97-AF65-F5344CB8AC3E}">
         <p14:creationId xmlns:p14="http://schemas.microsoft.com/office/powerpoint/2010/main" val="1431842015"/>
-      </p:ext>
-    </p:extLst>
-  </p:cSld>
-  <p:clrMapOvr>
-    <a:masterClrMapping/>
-  </p:clrMapOvr>
-</p:sld>
-</file>
-
-<file path=ppt/slides/slide11.xml><?xml version="1.0" encoding="utf-8"?>
-<p:sld xmlns:a="http://schemas.openxmlformats.org/drawingml/2006/main" xmlns:r="http://schemas.openxmlformats.org/officeDocument/2006/relationships" xmlns:p="http://schemas.openxmlformats.org/presentationml/2006/main">
-  <p:cSld>
-    <p:spTree>
-      <p:nvGrpSpPr>
-        <p:cNvPr id="1" name=""/>
-        <p:cNvGrpSpPr/>
-        <p:nvPr/>
-      </p:nvGrpSpPr>
-      <p:grpSpPr>
-        <a:xfrm>
-          <a:off x="0" y="0"/>
-          <a:ext cx="0" cy="0"/>
-          <a:chOff x="0" y="0"/>
-          <a:chExt cx="0" cy="0"/>
-        </a:xfrm>
-      </p:grpSpPr>
-      <p:sp>
-        <p:nvSpPr>
-          <p:cNvPr id="2" name="제목 1">
-            <a:extLst>
-              <a:ext uri="{FF2B5EF4-FFF2-40B4-BE49-F238E27FC236}">
-                <a16:creationId xmlns:a16="http://schemas.microsoft.com/office/drawing/2014/main" id="{2CD8C378-95FE-4A11-953A-87C911A3E4F8}"/>
-              </a:ext>
-            </a:extLst>
-          </p:cNvPr>
-          <p:cNvSpPr>
-            <a:spLocks noGrp="1"/>
-          </p:cNvSpPr>
-          <p:nvPr>
-            <p:ph type="title"/>
-          </p:nvPr>
-        </p:nvSpPr>
-        <p:spPr>
-          <a:xfrm>
-            <a:off x="407894" y="177427"/>
-            <a:ext cx="10515600" cy="898338"/>
-          </a:xfrm>
-        </p:spPr>
-        <p:txBody>
-          <a:bodyPr>
-            <a:normAutofit/>
-          </a:bodyPr>
-          <a:lstStyle/>
-          <a:p>
-            <a:r>
-              <a:rPr lang="ko-KR" altLang="en-US" sz="4000" dirty="0"/>
-              <a:t>주의점이나 고려할 점</a:t>
-            </a:r>
-          </a:p>
-        </p:txBody>
-      </p:sp>
-      <p:sp>
-        <p:nvSpPr>
-          <p:cNvPr id="5" name="내용 개체 틀 4">
-            <a:extLst>
-              <a:ext uri="{FF2B5EF4-FFF2-40B4-BE49-F238E27FC236}">
-                <a16:creationId xmlns:a16="http://schemas.microsoft.com/office/drawing/2014/main" id="{DFAB1F94-D79C-49AB-BC8A-FBFC879B3EEB}"/>
-              </a:ext>
-            </a:extLst>
-          </p:cNvPr>
-          <p:cNvSpPr>
-            <a:spLocks noGrp="1"/>
-          </p:cNvSpPr>
-          <p:nvPr>
-            <p:ph idx="1"/>
-          </p:nvPr>
-        </p:nvSpPr>
-        <p:spPr>
-          <a:xfrm>
-            <a:off x="497541" y="1201271"/>
-            <a:ext cx="9238130" cy="5979459"/>
-          </a:xfrm>
-        </p:spPr>
-        <p:txBody>
-          <a:bodyPr>
-            <a:normAutofit fontScale="55000" lnSpcReduction="20000"/>
-          </a:bodyPr>
-          <a:lstStyle/>
-          <a:p>
-            <a:pPr>
-              <a:lnSpc>
-                <a:spcPct val="145000"/>
-              </a:lnSpc>
-            </a:pPr>
-            <a:r>
-              <a:rPr lang="en-US" altLang="ko-KR" dirty="0"/>
-              <a:t>1. </a:t>
-            </a:r>
-            <a:r>
-              <a:rPr lang="ko-KR" altLang="en-US" dirty="0"/>
-              <a:t>우선순위가 잘못되면 의도와 다른 행동을 한다</a:t>
-            </a:r>
-            <a:r>
-              <a:rPr lang="en-US" altLang="ko-KR" dirty="0"/>
-              <a:t>.</a:t>
-            </a:r>
-          </a:p>
-          <a:p>
-            <a:pPr lvl="1">
-              <a:lnSpc>
-                <a:spcPct val="145000"/>
-              </a:lnSpc>
-            </a:pPr>
-            <a:r>
-              <a:rPr lang="ko-KR" altLang="en-US" dirty="0"/>
-              <a:t>예</a:t>
-            </a:r>
-            <a:r>
-              <a:rPr lang="en-US" altLang="ko-KR" dirty="0"/>
-              <a:t>: Reload</a:t>
-            </a:r>
-            <a:r>
-              <a:rPr lang="ko-KR" altLang="en-US" dirty="0"/>
-              <a:t>가 </a:t>
-            </a:r>
-            <a:r>
-              <a:rPr lang="en-US" altLang="ko-KR" dirty="0"/>
-              <a:t>Flee</a:t>
-            </a:r>
-            <a:r>
-              <a:rPr lang="ko-KR" altLang="en-US" dirty="0"/>
-              <a:t>보다 위에 있으면 위험한 상황에서도 장전할 수 있다</a:t>
-            </a:r>
-            <a:r>
-              <a:rPr lang="en-US" altLang="ko-KR" dirty="0"/>
-              <a:t>.</a:t>
-            </a:r>
-          </a:p>
-          <a:p>
-            <a:pPr>
-              <a:lnSpc>
-                <a:spcPct val="145000"/>
-              </a:lnSpc>
-            </a:pPr>
-            <a:endParaRPr lang="en-US" altLang="ko-KR" dirty="0"/>
-          </a:p>
-          <a:p>
-            <a:pPr>
-              <a:lnSpc>
-                <a:spcPct val="145000"/>
-              </a:lnSpc>
-            </a:pPr>
-            <a:r>
-              <a:rPr lang="en-US" altLang="ko-KR" dirty="0"/>
-              <a:t>2. </a:t>
-            </a:r>
-            <a:r>
-              <a:rPr lang="ko-KR" altLang="en-US" dirty="0"/>
-              <a:t>트리가 커지면 구조 자체가 복잡해질 수 있다</a:t>
-            </a:r>
-            <a:r>
-              <a:rPr lang="en-US" altLang="ko-KR" dirty="0"/>
-              <a:t>.</a:t>
-            </a:r>
-          </a:p>
-          <a:p>
-            <a:pPr lvl="1">
-              <a:lnSpc>
-                <a:spcPct val="145000"/>
-              </a:lnSpc>
-            </a:pPr>
-            <a:r>
-              <a:rPr lang="ko-KR" altLang="en-US" dirty="0"/>
-              <a:t>이름</a:t>
-            </a:r>
-            <a:r>
-              <a:rPr lang="en-US" altLang="ko-KR" dirty="0"/>
-              <a:t>, </a:t>
-            </a:r>
-            <a:r>
-              <a:rPr lang="ko-KR" altLang="en-US" dirty="0"/>
-              <a:t>계층</a:t>
-            </a:r>
-            <a:r>
-              <a:rPr lang="en-US" altLang="ko-KR" dirty="0"/>
-              <a:t>, </a:t>
-            </a:r>
-            <a:r>
-              <a:rPr lang="ko-KR" altLang="en-US" dirty="0"/>
-              <a:t>주석</a:t>
-            </a:r>
-            <a:r>
-              <a:rPr lang="en-US" altLang="ko-KR" dirty="0"/>
-              <a:t>, </a:t>
-            </a:r>
-            <a:r>
-              <a:rPr lang="ko-KR" altLang="en-US" dirty="0"/>
-              <a:t>디버깅 도구가 중요하다</a:t>
-            </a:r>
-            <a:r>
-              <a:rPr lang="en-US" altLang="ko-KR" dirty="0"/>
-              <a:t>.</a:t>
-            </a:r>
-          </a:p>
-          <a:p>
-            <a:pPr>
-              <a:lnSpc>
-                <a:spcPct val="145000"/>
-              </a:lnSpc>
-            </a:pPr>
-            <a:endParaRPr lang="en-US" altLang="ko-KR" dirty="0"/>
-          </a:p>
-          <a:p>
-            <a:pPr>
-              <a:lnSpc>
-                <a:spcPct val="145000"/>
-              </a:lnSpc>
-            </a:pPr>
-            <a:r>
-              <a:rPr lang="en-US" altLang="ko-KR" dirty="0"/>
-              <a:t>3. Running </a:t>
-            </a:r>
-            <a:r>
-              <a:rPr lang="ko-KR" altLang="en-US" dirty="0"/>
-              <a:t>상태 관리가 필요하다</a:t>
-            </a:r>
-            <a:r>
-              <a:rPr lang="en-US" altLang="ko-KR" dirty="0"/>
-              <a:t>. </a:t>
-            </a:r>
-          </a:p>
-          <a:p>
-            <a:pPr lvl="1">
-              <a:lnSpc>
-                <a:spcPct val="145000"/>
-              </a:lnSpc>
-            </a:pPr>
-            <a:r>
-              <a:rPr lang="ko-KR" altLang="en-US" dirty="0"/>
-              <a:t>이동</a:t>
-            </a:r>
-            <a:r>
-              <a:rPr lang="en-US" altLang="ko-KR" dirty="0"/>
-              <a:t>, </a:t>
-            </a:r>
-            <a:r>
-              <a:rPr lang="ko-KR" altLang="en-US" dirty="0"/>
-              <a:t>대기</a:t>
-            </a:r>
-            <a:r>
-              <a:rPr lang="en-US" altLang="ko-KR" dirty="0"/>
-              <a:t>, </a:t>
-            </a:r>
-            <a:r>
-              <a:rPr lang="ko-KR" altLang="en-US" dirty="0"/>
-              <a:t>애니메이션처럼 여러 프레임에 걸친 행동은 </a:t>
-            </a:r>
-            <a:r>
-              <a:rPr lang="en-US" altLang="ko-KR" dirty="0"/>
-              <a:t>reset</a:t>
-            </a:r>
-            <a:r>
-              <a:rPr lang="ko-KR" altLang="en-US" dirty="0"/>
-              <a:t>과 중단 처리를 신경 써야 한다</a:t>
-            </a:r>
-            <a:r>
-              <a:rPr lang="en-US" altLang="ko-KR" dirty="0"/>
-              <a:t>.</a:t>
-            </a:r>
-          </a:p>
-          <a:p>
-            <a:pPr>
-              <a:lnSpc>
-                <a:spcPct val="145000"/>
-              </a:lnSpc>
-            </a:pPr>
-            <a:endParaRPr lang="en-US" altLang="ko-KR" dirty="0"/>
-          </a:p>
-          <a:p>
-            <a:pPr>
-              <a:lnSpc>
-                <a:spcPct val="145000"/>
-              </a:lnSpc>
-            </a:pPr>
-            <a:r>
-              <a:rPr lang="en-US" altLang="ko-KR" dirty="0"/>
-              <a:t>4. </a:t>
-            </a:r>
-            <a:r>
-              <a:rPr lang="ko-KR" altLang="en-US" dirty="0"/>
-              <a:t>모든 걸 </a:t>
-            </a:r>
-            <a:r>
-              <a:rPr lang="en-US" altLang="ko-KR" dirty="0"/>
-              <a:t>BT</a:t>
-            </a:r>
-            <a:r>
-              <a:rPr lang="ko-KR" altLang="en-US" dirty="0"/>
-              <a:t>로 넣으면 오히려 부자연스럽다</a:t>
-            </a:r>
-            <a:r>
-              <a:rPr lang="en-US" altLang="ko-KR" dirty="0"/>
-              <a:t>. 	</a:t>
-            </a:r>
-          </a:p>
-          <a:p>
-            <a:pPr lvl="1">
-              <a:lnSpc>
-                <a:spcPct val="145000"/>
-              </a:lnSpc>
-            </a:pPr>
-            <a:r>
-              <a:rPr lang="en-US" altLang="ko-KR" dirty="0"/>
-              <a:t>Dead, Stunned, Dialogue, Cutscene </a:t>
-            </a:r>
-            <a:r>
-              <a:rPr lang="ko-KR" altLang="en-US" dirty="0"/>
-              <a:t>같은 큰 모드는 </a:t>
-            </a:r>
-            <a:r>
-              <a:rPr lang="en-US" altLang="ko-KR" dirty="0"/>
-              <a:t>FSM</a:t>
-            </a:r>
-            <a:r>
-              <a:rPr lang="ko-KR" altLang="en-US" dirty="0"/>
-              <a:t>이 더 적합하다</a:t>
-            </a:r>
-            <a:r>
-              <a:rPr lang="en-US" altLang="ko-KR" dirty="0"/>
-              <a:t>.</a:t>
-            </a:r>
-          </a:p>
-          <a:p>
-            <a:pPr>
-              <a:lnSpc>
-                <a:spcPct val="145000"/>
-              </a:lnSpc>
-            </a:pPr>
-            <a:endParaRPr lang="en-US" altLang="ko-KR" dirty="0"/>
-          </a:p>
-          <a:p>
-            <a:pPr>
-              <a:lnSpc>
-                <a:spcPct val="145000"/>
-              </a:lnSpc>
-            </a:pPr>
-            <a:r>
-              <a:rPr lang="en-US" altLang="ko-KR" dirty="0"/>
-              <a:t>5. </a:t>
-            </a:r>
-            <a:r>
-              <a:rPr lang="ko-KR" altLang="en-US" dirty="0"/>
-              <a:t>노드 객체 공유는 조심해야 한다</a:t>
-            </a:r>
-            <a:r>
-              <a:rPr lang="en-US" altLang="ko-KR" dirty="0"/>
-              <a:t>.</a:t>
-            </a:r>
-          </a:p>
-          <a:p>
-            <a:pPr lvl="1">
-              <a:lnSpc>
-                <a:spcPct val="145000"/>
-              </a:lnSpc>
-            </a:pPr>
-            <a:r>
-              <a:rPr lang="ko-KR" altLang="en-US" dirty="0"/>
-              <a:t>같은 조건 로직은 재사용해도</a:t>
-            </a:r>
-            <a:r>
-              <a:rPr lang="en-US" altLang="ko-KR" dirty="0"/>
-              <a:t>, </a:t>
-            </a:r>
-            <a:r>
-              <a:rPr lang="ko-KR" altLang="en-US" dirty="0"/>
-              <a:t>상태를 가진 노드 객체는 여러 위치에서 공유하지 않는 편이 안전하다</a:t>
-            </a:r>
-            <a:r>
-              <a:rPr lang="en-US" altLang="ko-KR" dirty="0"/>
-              <a:t>.</a:t>
-            </a:r>
-            <a:endParaRPr lang="ko-KR" altLang="en-US" dirty="0"/>
-          </a:p>
-        </p:txBody>
-      </p:sp>
-    </p:spTree>
-    <p:extLst>
-      <p:ext uri="{BB962C8B-B14F-4D97-AF65-F5344CB8AC3E}">
-        <p14:creationId xmlns:p14="http://schemas.microsoft.com/office/powerpoint/2010/main" val="1438579093"/>
       </p:ext>
     </p:extLst>
   </p:cSld>
@@ -4406,17 +4158,19 @@
         </p:nvSpPr>
         <p:spPr>
           <a:xfrm>
-            <a:off x="838200" y="69850"/>
+            <a:off x="332361" y="50394"/>
             <a:ext cx="10515600" cy="1325563"/>
           </a:xfrm>
         </p:spPr>
         <p:txBody>
-          <a:bodyPr/>
-          <a:lstStyle/>
-          <a:p>
-            <a:r>
-              <a:rPr lang="ko-KR" altLang="en-US" dirty="0"/>
-              <a:t>겪은 문제점</a:t>
+          <a:bodyPr>
+            <a:normAutofit/>
+          </a:bodyPr>
+          <a:lstStyle/>
+          <a:p>
+            <a:r>
+              <a:rPr lang="ko-KR" altLang="en-US" sz="3600" dirty="0"/>
+              <a:t>좀 불편했던 것</a:t>
             </a:r>
           </a:p>
         </p:txBody>
@@ -4439,116 +4193,149 @@
         </p:nvSpPr>
         <p:spPr>
           <a:xfrm>
-            <a:off x="838200" y="1568448"/>
-            <a:ext cx="10515600" cy="4937127"/>
+            <a:off x="332361" y="1317592"/>
+            <a:ext cx="10515600" cy="5392737"/>
           </a:xfrm>
         </p:spPr>
         <p:txBody>
           <a:bodyPr>
-            <a:normAutofit fontScale="92500" lnSpcReduction="10000"/>
+            <a:normAutofit/>
           </a:bodyPr>
           <a:lstStyle/>
           <a:p>
-            <a:r>
-              <a:rPr lang="ko-KR" altLang="en-US" dirty="0"/>
-              <a:t>“체력이 낮으면 도망간다” 같은 공통 규칙도</a:t>
+            <a:pPr>
+              <a:lnSpc>
+                <a:spcPct val="125000"/>
+              </a:lnSpc>
+            </a:pPr>
+            <a:r>
+              <a:rPr lang="ko-KR" altLang="en-US" sz="2000" dirty="0"/>
+              <a:t>“체력이 낮으면 도망간다” 같은 공통 규칙도 상태마다 우선순위가 다를 수 있기 때문에</a:t>
+            </a:r>
+            <a:r>
+              <a:rPr lang="en-US" altLang="ko-KR" sz="2000" dirty="0"/>
+              <a:t>, </a:t>
+            </a:r>
+            <a:r>
+              <a:rPr lang="ko-KR" altLang="en-US" sz="2000" dirty="0"/>
+              <a:t>상위 클래스의 </a:t>
+            </a:r>
+            <a:r>
+              <a:rPr lang="en-US" altLang="ko-KR" sz="2000" dirty="0"/>
+              <a:t>update</a:t>
+            </a:r>
+            <a:r>
+              <a:rPr lang="ko-KR" altLang="en-US" sz="2000" dirty="0"/>
+              <a:t>에 그냥 넣을 수 없으므로 여러 상태에 각각 넣어준다</a:t>
+            </a:r>
+            <a:r>
+              <a:rPr lang="en-US" altLang="ko-KR" sz="2000" dirty="0"/>
+              <a:t>.</a:t>
+            </a:r>
+          </a:p>
+          <a:p>
+            <a:pPr>
+              <a:lnSpc>
+                <a:spcPct val="125000"/>
+              </a:lnSpc>
+            </a:pPr>
+            <a:endParaRPr lang="en-US" altLang="ko-KR" sz="2000" dirty="0"/>
+          </a:p>
+          <a:p>
+            <a:pPr>
+              <a:lnSpc>
+                <a:spcPct val="125000"/>
+              </a:lnSpc>
+            </a:pPr>
+            <a:r>
+              <a:rPr lang="en-US" altLang="ko-KR" sz="2000" dirty="0"/>
+              <a:t>Attack -&gt; Flee</a:t>
+            </a:r>
+          </a:p>
+          <a:p>
+            <a:pPr>
+              <a:lnSpc>
+                <a:spcPct val="125000"/>
+              </a:lnSpc>
+            </a:pPr>
+            <a:r>
+              <a:rPr lang="en-US" altLang="ko-KR" sz="2000" dirty="0"/>
+              <a:t>Chase -&gt; Flee</a:t>
+            </a:r>
+          </a:p>
+          <a:p>
+            <a:pPr>
+              <a:lnSpc>
+                <a:spcPct val="125000"/>
+              </a:lnSpc>
+            </a:pPr>
+            <a:r>
+              <a:rPr lang="en-US" altLang="ko-KR" sz="2000" dirty="0"/>
+              <a:t>Reload -&gt; Flee</a:t>
+            </a:r>
+          </a:p>
+          <a:p>
+            <a:pPr>
+              <a:lnSpc>
+                <a:spcPct val="125000"/>
+              </a:lnSpc>
+            </a:pPr>
+            <a:r>
+              <a:rPr lang="en-US" altLang="ko-KR" sz="2000" dirty="0"/>
+              <a:t>Search -&gt; Flee</a:t>
+            </a:r>
+          </a:p>
+          <a:p>
+            <a:pPr>
+              <a:lnSpc>
+                <a:spcPct val="125000"/>
+              </a:lnSpc>
+            </a:pPr>
+            <a:endParaRPr lang="en-US" altLang="ko-KR" sz="2000" dirty="0"/>
+          </a:p>
+          <a:p>
+            <a:pPr>
+              <a:lnSpc>
+                <a:spcPct val="125000"/>
+              </a:lnSpc>
+            </a:pPr>
+            <a:r>
+              <a:rPr lang="ko-KR" altLang="en-US" sz="2000" dirty="0"/>
+              <a:t>상태 전이가 복잡해질 때 조건 분기가 흩어지고 많아진다</a:t>
+            </a:r>
+            <a:r>
+              <a:rPr lang="en-US" altLang="ko-KR" sz="2000" dirty="0"/>
+              <a:t>.</a:t>
             </a:r>
           </a:p>
           <a:p>
             <a:pPr marL="0" indent="0">
+              <a:lnSpc>
+                <a:spcPct val="125000"/>
+              </a:lnSpc>
               <a:buNone/>
             </a:pPr>
             <a:r>
-              <a:rPr lang="ko-KR" altLang="en-US" dirty="0"/>
-              <a:t>   여러 상태에 반복해서 들어간다</a:t>
-            </a:r>
-            <a:r>
-              <a:rPr lang="en-US" altLang="ko-KR" dirty="0"/>
-              <a:t>.</a:t>
-            </a:r>
-          </a:p>
-          <a:p>
-            <a:endParaRPr lang="en-US" altLang="ko-KR" dirty="0"/>
-          </a:p>
-          <a:p>
-            <a:r>
-              <a:rPr lang="en-US" altLang="ko-KR" dirty="0"/>
-              <a:t>Attack -&gt; Flee</a:t>
-            </a:r>
-          </a:p>
-          <a:p>
-            <a:r>
-              <a:rPr lang="en-US" altLang="ko-KR" dirty="0"/>
-              <a:t>Chase -&gt; Flee</a:t>
-            </a:r>
-          </a:p>
-          <a:p>
-            <a:r>
-              <a:rPr lang="en-US" altLang="ko-KR" dirty="0"/>
-              <a:t>Reload -&gt; Flee</a:t>
-            </a:r>
-          </a:p>
-          <a:p>
-            <a:r>
-              <a:rPr lang="en-US" altLang="ko-KR" dirty="0"/>
-              <a:t>Search -&gt; Flee</a:t>
-            </a:r>
-          </a:p>
-          <a:p>
-            <a:endParaRPr lang="en-US" altLang="ko-KR" dirty="0"/>
-          </a:p>
-          <a:p>
-            <a:r>
-              <a:rPr lang="ko-KR" altLang="en-US" dirty="0"/>
-              <a:t>상태 전이가 복잡해질 때</a:t>
-            </a:r>
-            <a:r>
-              <a:rPr lang="en-US" altLang="ko-KR" dirty="0"/>
-              <a:t>,</a:t>
-            </a:r>
-          </a:p>
-          <a:p>
-            <a:pPr marL="0" indent="0">
-              <a:buNone/>
-            </a:pPr>
-            <a:r>
-              <a:rPr lang="en-US" altLang="ko-KR" dirty="0"/>
-              <a:t>  FSM</a:t>
-            </a:r>
-            <a:r>
-              <a:rPr lang="ko-KR" altLang="en-US" dirty="0"/>
-              <a:t>만으로는 조건 분기가 흩어지고 많아진다</a:t>
-            </a:r>
-            <a:r>
-              <a:rPr lang="en-US" altLang="ko-KR" dirty="0"/>
-              <a:t>.</a:t>
-            </a:r>
-          </a:p>
-          <a:p>
-            <a:pPr marL="0" indent="0">
-              <a:buNone/>
-            </a:pPr>
-            <a:r>
-              <a:rPr lang="en-US" altLang="ko-KR" dirty="0"/>
+              <a:rPr lang="en-US" altLang="ko-KR" sz="2000" dirty="0"/>
               <a:t>  -&gt; </a:t>
             </a:r>
             <a:r>
-              <a:rPr lang="ko-KR" altLang="en-US" dirty="0"/>
+              <a:rPr lang="ko-KR" altLang="en-US" sz="2000" dirty="0"/>
               <a:t>상태가 늘어날수록 전이 조건 </a:t>
             </a:r>
             <a:r>
-              <a:rPr lang="en-US" altLang="ko-KR" dirty="0"/>
+              <a:rPr lang="en-US" altLang="ko-KR" sz="2000" dirty="0"/>
               <a:t>if</a:t>
             </a:r>
             <a:r>
-              <a:rPr lang="ko-KR" altLang="en-US" dirty="0"/>
+              <a:rPr lang="ko-KR" altLang="en-US" sz="2000" dirty="0"/>
               <a:t>문이 계속 </a:t>
             </a:r>
             <a:r>
-              <a:rPr lang="ko-KR" altLang="en-US" dirty="0" err="1"/>
+              <a:rPr lang="ko-KR" altLang="en-US" sz="2000" dirty="0" err="1"/>
               <a:t>증가했슨</a:t>
             </a:r>
-            <a:endParaRPr lang="ko-KR" altLang="en-US" dirty="0"/>
+            <a:endParaRPr lang="ko-KR" altLang="en-US" sz="2000" dirty="0"/>
           </a:p>
         </p:txBody>
       </p:sp>
@@ -4574,8 +4361,8 @@
         </p:blipFill>
         <p:spPr>
           <a:xfrm>
-            <a:off x="8096187" y="1887730"/>
-            <a:ext cx="3819588" cy="3401822"/>
+            <a:off x="2888648" y="2398309"/>
+            <a:ext cx="2999830" cy="2671725"/>
           </a:xfrm>
           <a:prstGeom prst="rect">
             <a:avLst/>
@@ -4672,7 +4459,7 @@
         </p:nvSpPr>
         <p:spPr>
           <a:xfrm>
-            <a:off x="838200" y="1225549"/>
+            <a:off x="559340" y="1395413"/>
             <a:ext cx="10515600" cy="3308352"/>
           </a:xfrm>
         </p:spPr>
@@ -4683,59 +4470,59 @@
           <a:lstStyle/>
           <a:p>
             <a:r>
-              <a:rPr lang="en-US" altLang="ko-KR" sz="2400" dirty="0"/>
+              <a:rPr lang="en-US" altLang="ko-KR" sz="2000" dirty="0"/>
               <a:t>FSM:</a:t>
             </a:r>
           </a:p>
           <a:p>
             <a:r>
-              <a:rPr lang="ko-KR" altLang="en-US" sz="2400" dirty="0"/>
+              <a:rPr lang="ko-KR" altLang="en-US" sz="2000" dirty="0"/>
               <a:t>지금 어떤 상태인가</a:t>
             </a:r>
             <a:r>
-              <a:rPr lang="en-US" altLang="ko-KR" sz="2400" dirty="0"/>
+              <a:rPr lang="en-US" altLang="ko-KR" sz="2000" dirty="0"/>
               <a:t>?</a:t>
             </a:r>
           </a:p>
           <a:p>
             <a:r>
-              <a:rPr lang="ko-KR" altLang="en-US" sz="2400" dirty="0"/>
+              <a:rPr lang="ko-KR" altLang="en-US" sz="2000" dirty="0"/>
               <a:t>이 상태에서 어디로 전이할 수 있는가</a:t>
             </a:r>
             <a:r>
-              <a:rPr lang="en-US" altLang="ko-KR" sz="2400" dirty="0"/>
+              <a:rPr lang="en-US" altLang="ko-KR" sz="2000" dirty="0"/>
               <a:t>?</a:t>
             </a:r>
           </a:p>
           <a:p>
-            <a:endParaRPr lang="en-US" altLang="ko-KR" sz="2400" dirty="0"/>
-          </a:p>
-          <a:p>
-            <a:r>
-              <a:rPr lang="en-US" altLang="ko-KR" sz="2400" dirty="0"/>
+            <a:endParaRPr lang="en-US" altLang="ko-KR" sz="2000" dirty="0"/>
+          </a:p>
+          <a:p>
+            <a:r>
+              <a:rPr lang="en-US" altLang="ko-KR" sz="2000" dirty="0"/>
               <a:t>BT:</a:t>
             </a:r>
           </a:p>
           <a:p>
             <a:r>
-              <a:rPr lang="ko-KR" altLang="en-US" sz="2400" dirty="0"/>
+              <a:rPr lang="ko-KR" altLang="en-US" sz="2000" dirty="0"/>
               <a:t>지금 가장 우선순위가 높은 행동은 무엇인가</a:t>
             </a:r>
             <a:r>
-              <a:rPr lang="en-US" altLang="ko-KR" sz="2400" dirty="0"/>
+              <a:rPr lang="en-US" altLang="ko-KR" sz="2000" dirty="0"/>
               <a:t>?</a:t>
             </a:r>
           </a:p>
           <a:p>
             <a:r>
-              <a:rPr lang="ko-KR" altLang="en-US" sz="2400" dirty="0"/>
+              <a:rPr lang="ko-KR" altLang="en-US" sz="2000" dirty="0"/>
               <a:t>어떤 조건을 만족하면 어떤 행동을 할 것인가</a:t>
             </a:r>
             <a:r>
-              <a:rPr lang="en-US" altLang="ko-KR" sz="2400" dirty="0"/>
+              <a:rPr lang="en-US" altLang="ko-KR" sz="2000" dirty="0"/>
               <a:t>?</a:t>
             </a:r>
-            <a:endParaRPr lang="ko-KR" altLang="en-US" sz="2400" dirty="0"/>
+            <a:endParaRPr lang="ko-KR" altLang="en-US" sz="2000" dirty="0"/>
           </a:p>
         </p:txBody>
       </p:sp>
@@ -4753,8 +4540,8 @@
         </p:nvSpPr>
         <p:spPr>
           <a:xfrm>
-            <a:off x="2624138" y="4678344"/>
-            <a:ext cx="7734300" cy="830997"/>
+            <a:off x="1729193" y="4603712"/>
+            <a:ext cx="7734300" cy="707886"/>
           </a:xfrm>
           <a:prstGeom prst="rect">
             <a:avLst/>
@@ -4768,13 +4555,13 @@
           <a:lstStyle/>
           <a:p>
             <a:r>
-              <a:rPr lang="ko-KR" altLang="en-US" sz="2400" dirty="0"/>
+              <a:rPr lang="ko-KR" altLang="en-US" sz="2000" dirty="0"/>
               <a:t>FSM = 상태와 전이 관리</a:t>
             </a:r>
           </a:p>
           <a:p>
             <a:r>
-              <a:rPr lang="ko-KR" altLang="en-US" sz="2400" dirty="0"/>
+              <a:rPr lang="ko-KR" altLang="en-US" sz="2000" dirty="0"/>
               <a:t>BT = 조건과 행동의 우선순위 관리</a:t>
             </a:r>
           </a:p>
@@ -4794,8 +4581,8 @@
         </p:nvSpPr>
         <p:spPr>
           <a:xfrm>
-            <a:off x="838200" y="4893787"/>
-            <a:ext cx="1400175" cy="461665"/>
+            <a:off x="617706" y="4757600"/>
+            <a:ext cx="1400175" cy="400110"/>
           </a:xfrm>
           <a:prstGeom prst="rect">
             <a:avLst/>
@@ -4809,14 +4596,14 @@
           <a:lstStyle/>
           <a:p>
             <a:r>
-              <a:rPr lang="ko-KR" altLang="en-US" sz="2400" dirty="0"/>
+              <a:rPr lang="ko-KR" altLang="en-US" sz="2000" dirty="0"/>
               <a:t>비교 </a:t>
             </a:r>
             <a:r>
-              <a:rPr lang="en-US" altLang="ko-KR" sz="2400" dirty="0"/>
+              <a:rPr lang="en-US" altLang="ko-KR" sz="2000" dirty="0"/>
               <a:t>:</a:t>
             </a:r>
-            <a:endParaRPr lang="ko-KR" altLang="en-US" sz="2400" dirty="0"/>
+            <a:endParaRPr lang="ko-KR" altLang="en-US" sz="2000" dirty="0"/>
           </a:p>
         </p:txBody>
       </p:sp>
@@ -4834,8 +4621,8 @@
         </p:nvSpPr>
         <p:spPr>
           <a:xfrm>
-            <a:off x="838200" y="5894569"/>
-            <a:ext cx="9086850" cy="461665"/>
+            <a:off x="559340" y="5629218"/>
+            <a:ext cx="7410856" cy="400110"/>
           </a:xfrm>
           <a:prstGeom prst="rect">
             <a:avLst/>
@@ -4849,7 +4636,7 @@
           <a:lstStyle/>
           <a:p>
             <a:r>
-              <a:rPr lang="ko-KR" altLang="en-US" sz="2400" dirty="0">
+              <a:rPr lang="ko-KR" altLang="en-US" sz="2000" dirty="0">
                 <a:highlight>
                   <a:srgbClr val="C0C0C0"/>
                 </a:highlight>
@@ -4857,7 +4644,7 @@
               <a:t>행동 선택지가 많고 우선순위가 </a:t>
             </a:r>
             <a:r>
-              <a:rPr lang="ko-KR" altLang="en-US" sz="2400" dirty="0" err="1">
+              <a:rPr lang="ko-KR" altLang="en-US" sz="2000" dirty="0" err="1">
                 <a:highlight>
                   <a:srgbClr val="C0C0C0"/>
                 </a:highlight>
@@ -4865,7 +4652,7 @@
               <a:t>중요해질수록</a:t>
             </a:r>
             <a:r>
-              <a:rPr lang="ko-KR" altLang="en-US" sz="2400" dirty="0">
+              <a:rPr lang="ko-KR" altLang="en-US" sz="2000" dirty="0">
                 <a:highlight>
                   <a:srgbClr val="C0C0C0"/>
                 </a:highlight>
@@ -4873,7 +4660,7 @@
               <a:t> </a:t>
             </a:r>
             <a:r>
-              <a:rPr lang="ko-KR" altLang="en-US" sz="2400" dirty="0" err="1">
+              <a:rPr lang="ko-KR" altLang="en-US" sz="2000" dirty="0" err="1">
                 <a:highlight>
                   <a:srgbClr val="C0C0C0"/>
                 </a:highlight>
@@ -4881,13 +4668,57 @@
               <a:t>BT가</a:t>
             </a:r>
             <a:r>
-              <a:rPr lang="ko-KR" altLang="en-US" sz="2400" dirty="0">
+              <a:rPr lang="ko-KR" altLang="en-US" sz="2000" dirty="0">
                 <a:highlight>
                   <a:srgbClr val="C0C0C0"/>
                 </a:highlight>
               </a:rPr>
               <a:t> 유리해진다.</a:t>
             </a:r>
+          </a:p>
+        </p:txBody>
+      </p:sp>
+      <p:sp>
+        <p:nvSpPr>
+          <p:cNvPr id="7" name="TextBox 6">
+            <a:extLst>
+              <a:ext uri="{FF2B5EF4-FFF2-40B4-BE49-F238E27FC236}">
+                <a16:creationId xmlns:a16="http://schemas.microsoft.com/office/drawing/2014/main" id="{692F47F1-FC82-4E37-8193-CDED59BF5E24}"/>
+              </a:ext>
+            </a:extLst>
+          </p:cNvPr>
+          <p:cNvSpPr txBox="1"/>
+          <p:nvPr/>
+        </p:nvSpPr>
+        <p:spPr>
+          <a:xfrm>
+            <a:off x="8114488" y="5629218"/>
+            <a:ext cx="2456235" cy="400110"/>
+          </a:xfrm>
+          <a:prstGeom prst="rect">
+            <a:avLst/>
+          </a:prstGeom>
+          <a:noFill/>
+        </p:spPr>
+        <p:txBody>
+          <a:bodyPr wrap="square">
+            <a:spAutoFit/>
+          </a:bodyPr>
+          <a:lstStyle/>
+          <a:p>
+            <a:r>
+              <a:rPr lang="ko-KR" altLang="en-US" sz="2000" dirty="0" err="1"/>
+              <a:t>라고</a:t>
+            </a:r>
+            <a:r>
+              <a:rPr lang="ko-KR" altLang="en-US" sz="2000" dirty="0"/>
+              <a:t> </a:t>
+            </a:r>
+            <a:r>
+              <a:rPr lang="ko-KR" altLang="en-US" sz="2000" dirty="0" err="1"/>
+              <a:t>말했었는데요</a:t>
+            </a:r>
+            <a:endParaRPr lang="ko-KR" altLang="en-US" sz="2000" dirty="0"/>
           </a:p>
         </p:txBody>
       </p:sp>
@@ -4901,6 +4732,84 @@
   <p:clrMapOvr>
     <a:masterClrMapping/>
   </p:clrMapOvr>
+  <p:timing>
+    <p:tnLst>
+      <p:par>
+        <p:cTn id="1" dur="indefinite" restart="never" nodeType="tmRoot">
+          <p:childTnLst>
+            <p:seq concurrent="1" nextAc="seek">
+              <p:cTn id="2" dur="indefinite" nodeType="mainSeq">
+                <p:childTnLst>
+                  <p:par>
+                    <p:cTn id="3" fill="hold">
+                      <p:stCondLst>
+                        <p:cond delay="indefinite"/>
+                      </p:stCondLst>
+                      <p:childTnLst>
+                        <p:par>
+                          <p:cTn id="4" fill="hold">
+                            <p:stCondLst>
+                              <p:cond delay="0"/>
+                            </p:stCondLst>
+                            <p:childTnLst>
+                              <p:par>
+                                <p:cTn id="5" presetID="1" presetClass="entr" presetSubtype="0" fill="hold" grpId="0" nodeType="clickEffect">
+                                  <p:stCondLst>
+                                    <p:cond delay="0"/>
+                                  </p:stCondLst>
+                                  <p:childTnLst>
+                                    <p:set>
+                                      <p:cBhvr>
+                                        <p:cTn id="6" dur="1" fill="hold">
+                                          <p:stCondLst>
+                                            <p:cond delay="0"/>
+                                          </p:stCondLst>
+                                        </p:cTn>
+                                        <p:tgtEl>
+                                          <p:spTgt spid="7"/>
+                                        </p:tgtEl>
+                                        <p:attrNameLst>
+                                          <p:attrName>style.visibility</p:attrName>
+                                        </p:attrNameLst>
+                                      </p:cBhvr>
+                                      <p:to>
+                                        <p:strVal val="visible"/>
+                                      </p:to>
+                                    </p:set>
+                                  </p:childTnLst>
+                                </p:cTn>
+                              </p:par>
+                            </p:childTnLst>
+                          </p:cTn>
+                        </p:par>
+                      </p:childTnLst>
+                    </p:cTn>
+                  </p:par>
+                </p:childTnLst>
+              </p:cTn>
+              <p:prevCondLst>
+                <p:cond evt="onPrev" delay="0">
+                  <p:tgtEl>
+                    <p:sldTgt/>
+                  </p:tgtEl>
+                </p:cond>
+              </p:prevCondLst>
+              <p:nextCondLst>
+                <p:cond evt="onNext" delay="0">
+                  <p:tgtEl>
+                    <p:sldTgt/>
+                  </p:tgtEl>
+                </p:cond>
+              </p:nextCondLst>
+            </p:seq>
+          </p:childTnLst>
+        </p:cTn>
+      </p:par>
+    </p:tnLst>
+    <p:bldLst>
+      <p:bldP spid="7" grpId="0"/>
+    </p:bldLst>
+  </p:timing>
 </p:sld>
 </file>
 
@@ -4939,54 +4848,56 @@
         </p:nvSpPr>
         <p:spPr>
           <a:xfrm>
-            <a:off x="838200" y="69850"/>
+            <a:off x="526914" y="69850"/>
             <a:ext cx="10515600" cy="1325563"/>
           </a:xfrm>
         </p:spPr>
         <p:txBody>
-          <a:bodyPr/>
-          <a:lstStyle/>
-          <a:p>
-            <a:r>
-              <a:rPr lang="en-US" altLang="ko-KR" dirty="0"/>
-              <a:t>BT</a:t>
-            </a:r>
-            <a:r>
-              <a:rPr lang="ko-KR" altLang="en-US" dirty="0"/>
-              <a:t>는 노드로 구성되어 있습니다</a:t>
-            </a:r>
-          </a:p>
-        </p:txBody>
-      </p:sp>
-      <p:sp>
-        <p:nvSpPr>
-          <p:cNvPr id="3" name="내용 개체 틀 2">
-            <a:extLst>
-              <a:ext uri="{FF2B5EF4-FFF2-40B4-BE49-F238E27FC236}">
-                <a16:creationId xmlns:a16="http://schemas.microsoft.com/office/drawing/2014/main" id="{578179D0-6416-4939-9907-B677FF860F6B}"/>
-              </a:ext>
-            </a:extLst>
-          </p:cNvPr>
-          <p:cNvSpPr>
-            <a:spLocks noGrp="1"/>
-          </p:cNvSpPr>
-          <p:nvPr>
-            <p:ph idx="1"/>
-          </p:nvPr>
-        </p:nvSpPr>
-        <p:spPr>
-          <a:xfrm>
-            <a:off x="647700" y="1395413"/>
-            <a:ext cx="8972550" cy="5053012"/>
-          </a:xfrm>
-        </p:spPr>
-        <p:txBody>
           <a:bodyPr>
             <a:normAutofit/>
           </a:bodyPr>
           <a:lstStyle/>
           <a:p>
             <a:r>
+              <a:rPr lang="en-US" altLang="ko-KR" sz="4000" dirty="0"/>
+              <a:t>BT</a:t>
+            </a:r>
+            <a:r>
+              <a:rPr lang="ko-KR" altLang="en-US" sz="4000" dirty="0"/>
+              <a:t>의 구성</a:t>
+            </a:r>
+          </a:p>
+        </p:txBody>
+      </p:sp>
+      <p:sp>
+        <p:nvSpPr>
+          <p:cNvPr id="3" name="내용 개체 틀 2">
+            <a:extLst>
+              <a:ext uri="{FF2B5EF4-FFF2-40B4-BE49-F238E27FC236}">
+                <a16:creationId xmlns:a16="http://schemas.microsoft.com/office/drawing/2014/main" id="{578179D0-6416-4939-9907-B677FF860F6B}"/>
+              </a:ext>
+            </a:extLst>
+          </p:cNvPr>
+          <p:cNvSpPr>
+            <a:spLocks noGrp="1"/>
+          </p:cNvSpPr>
+          <p:nvPr>
+            <p:ph idx="1"/>
+          </p:nvPr>
+        </p:nvSpPr>
+        <p:spPr>
+          <a:xfrm>
+            <a:off x="401266" y="1395412"/>
+            <a:ext cx="8972550" cy="5342613"/>
+          </a:xfrm>
+        </p:spPr>
+        <p:txBody>
+          <a:bodyPr>
+            <a:normAutofit fontScale="92500" lnSpcReduction="10000"/>
+          </a:bodyPr>
+          <a:lstStyle/>
+          <a:p>
+            <a:r>
               <a:rPr lang="en-US" altLang="ko-KR" sz="2400" dirty="0"/>
               <a:t>Selector:</a:t>
             </a:r>
@@ -5000,6 +4911,22 @@
             <a:endParaRPr lang="en-US" altLang="ko-KR" sz="2000" dirty="0"/>
           </a:p>
           <a:p>
+            <a:pPr lvl="1"/>
+            <a:r>
+              <a:rPr lang="ko-KR" altLang="en-US" sz="2000" dirty="0"/>
+              <a:t>자식을 위에서부터 확인</a:t>
+            </a:r>
+            <a:endParaRPr lang="en-US" altLang="ko-KR" sz="1600" dirty="0"/>
+          </a:p>
+          <a:p>
+            <a:pPr lvl="1"/>
+            <a:r>
+              <a:rPr lang="ko-KR" altLang="en-US" sz="2000" dirty="0"/>
+              <a:t>성공하면 아래는 안 봄</a:t>
+            </a:r>
+            <a:endParaRPr lang="en-US" altLang="ko-KR" sz="2000" dirty="0"/>
+          </a:p>
+          <a:p>
             <a:endParaRPr lang="en-US" altLang="ko-KR" sz="2400" dirty="0"/>
           </a:p>
           <a:p>
@@ -5026,6 +4953,30 @@
               <a:rPr lang="en-US" altLang="ko-KR" sz="2000" dirty="0"/>
               <a:t>.</a:t>
             </a:r>
+          </a:p>
+          <a:p>
+            <a:pPr lvl="1"/>
+            <a:r>
+              <a:rPr lang="ko-KR" altLang="en-US" sz="2000" dirty="0"/>
+              <a:t>여러 </a:t>
+            </a:r>
+            <a:r>
+              <a:rPr lang="en-US" altLang="ko-KR" sz="2000" dirty="0"/>
+              <a:t>Condition</a:t>
+            </a:r>
+            <a:r>
+              <a:rPr lang="ko-KR" altLang="en-US" sz="2000" dirty="0"/>
+              <a:t>을 조합해 다 부합하면 </a:t>
+            </a:r>
+            <a:r>
+              <a:rPr lang="en-US" altLang="ko-KR" sz="2000" dirty="0"/>
+              <a:t>Action</a:t>
+            </a:r>
+            <a:r>
+              <a:rPr lang="ko-KR" altLang="en-US" sz="2000" dirty="0"/>
+              <a:t>을 수행</a:t>
+            </a:r>
+            <a:endParaRPr lang="en-US" altLang="ko-KR" sz="2000" dirty="0"/>
           </a:p>
           <a:p>
             <a:pPr lvl="1"/>
@@ -5092,7 +5043,7 @@
         </p:blipFill>
         <p:spPr>
           <a:xfrm>
-            <a:off x="7597727" y="1916211"/>
+            <a:off x="7495779" y="1217710"/>
             <a:ext cx="3756073" cy="4244878"/>
           </a:xfrm>
           <a:prstGeom prst="rect">
@@ -5100,6 +5051,63 @@
           </a:prstGeom>
         </p:spPr>
       </p:pic>
+      <p:sp>
+        <p:nvSpPr>
+          <p:cNvPr id="6" name="TextBox 5">
+            <a:extLst>
+              <a:ext uri="{FF2B5EF4-FFF2-40B4-BE49-F238E27FC236}">
+                <a16:creationId xmlns:a16="http://schemas.microsoft.com/office/drawing/2014/main" id="{388C5CC2-5C6A-4D5C-AFF2-3AEB4FB80D42}"/>
+              </a:ext>
+            </a:extLst>
+          </p:cNvPr>
+          <p:cNvSpPr txBox="1"/>
+          <p:nvPr/>
+        </p:nvSpPr>
+        <p:spPr>
+          <a:xfrm>
+            <a:off x="6860432" y="5740836"/>
+            <a:ext cx="5182410" cy="646331"/>
+          </a:xfrm>
+          <a:prstGeom prst="rect">
+            <a:avLst/>
+          </a:prstGeom>
+          <a:noFill/>
+        </p:spPr>
+        <p:txBody>
+          <a:bodyPr wrap="square">
+            <a:spAutoFit/>
+          </a:bodyPr>
+          <a:lstStyle/>
+          <a:p>
+            <a:r>
+              <a:rPr lang="ko-KR" altLang="en-US" dirty="0"/>
+              <a:t>체력이 낮으면 공격 가능해도 도망간다.</a:t>
+            </a:r>
+          </a:p>
+          <a:p>
+            <a:r>
+              <a:rPr lang="ko-KR" altLang="en-US" dirty="0"/>
+              <a:t>왜냐하면 </a:t>
+            </a:r>
+            <a:r>
+              <a:rPr lang="ko-KR" altLang="en-US" dirty="0" err="1"/>
+              <a:t>Flee가</a:t>
+            </a:r>
+            <a:r>
+              <a:rPr lang="ko-KR" altLang="en-US" dirty="0"/>
+              <a:t> </a:t>
+            </a:r>
+            <a:r>
+              <a:rPr lang="ko-KR" altLang="en-US" dirty="0" err="1"/>
+              <a:t>Attack보다</a:t>
+            </a:r>
+            <a:r>
+              <a:rPr lang="ko-KR" altLang="en-US" dirty="0"/>
+              <a:t> 위에 있기 때문이다.</a:t>
+            </a:r>
+          </a:p>
+        </p:txBody>
+      </p:sp>
     </p:spTree>
     <p:extLst>
       <p:ext uri="{BB962C8B-B14F-4D97-AF65-F5344CB8AC3E}">
@@ -5132,10 +5140,10 @@
       </p:grpSpPr>
       <p:sp>
         <p:nvSpPr>
-          <p:cNvPr id="2" name="제목 1">
-            <a:extLst>
-              <a:ext uri="{FF2B5EF4-FFF2-40B4-BE49-F238E27FC236}">
-                <a16:creationId xmlns:a16="http://schemas.microsoft.com/office/drawing/2014/main" id="{2CD8C378-95FE-4A11-953A-87C911A3E4F8}"/>
+          <p:cNvPr id="4" name="제목 3">
+            <a:extLst>
+              <a:ext uri="{FF2B5EF4-FFF2-40B4-BE49-F238E27FC236}">
+                <a16:creationId xmlns:a16="http://schemas.microsoft.com/office/drawing/2014/main" id="{E5D2AEA2-0E02-4D66-BE86-7A6D9006D4B9}"/>
               </a:ext>
             </a:extLst>
           </p:cNvPr>
@@ -5146,102 +5154,21 @@
             <p:ph type="title"/>
           </p:nvPr>
         </p:nvSpPr>
-        <p:spPr>
-          <a:xfrm>
-            <a:off x="838200" y="69850"/>
-            <a:ext cx="10515600" cy="1325563"/>
-          </a:xfrm>
-        </p:spPr>
-        <p:txBody>
-          <a:bodyPr>
-            <a:normAutofit/>
-          </a:bodyPr>
-          <a:lstStyle/>
-          <a:p>
-            <a:r>
-              <a:rPr lang="en-US" altLang="ko-KR" sz="4000" dirty="0"/>
-              <a:t>Sequence</a:t>
-            </a:r>
-            <a:r>
-              <a:rPr lang="ko-KR" altLang="en-US" sz="4000" dirty="0"/>
-              <a:t>는 조건 조합</a:t>
-            </a:r>
-            <a:r>
-              <a:rPr lang="en-US" altLang="ko-KR" sz="4000" dirty="0"/>
-              <a:t>, Selector</a:t>
-            </a:r>
-            <a:r>
-              <a:rPr lang="ko-KR" altLang="en-US" sz="4000" dirty="0"/>
-              <a:t>는 우선순위</a:t>
-            </a:r>
-          </a:p>
-        </p:txBody>
-      </p:sp>
-      <p:sp>
-        <p:nvSpPr>
-          <p:cNvPr id="3" name="내용 개체 틀 2">
-            <a:extLst>
-              <a:ext uri="{FF2B5EF4-FFF2-40B4-BE49-F238E27FC236}">
-                <a16:creationId xmlns:a16="http://schemas.microsoft.com/office/drawing/2014/main" id="{578179D0-6416-4939-9907-B677FF860F6B}"/>
-              </a:ext>
-            </a:extLst>
-          </p:cNvPr>
-          <p:cNvSpPr>
-            <a:spLocks noGrp="1"/>
-          </p:cNvSpPr>
-          <p:nvPr>
-            <p:ph idx="1"/>
-          </p:nvPr>
-        </p:nvSpPr>
-        <p:spPr>
-          <a:xfrm>
-            <a:off x="647700" y="1395413"/>
-            <a:ext cx="8972550" cy="1033462"/>
-          </a:xfrm>
-        </p:spPr>
-        <p:txBody>
-          <a:bodyPr>
-            <a:normAutofit/>
-          </a:bodyPr>
-          <a:lstStyle/>
-          <a:p>
-            <a:r>
-              <a:rPr lang="en-US" altLang="ko-KR" sz="2400" dirty="0"/>
-              <a:t>Sequence</a:t>
-            </a:r>
-          </a:p>
-          <a:p>
-            <a:pPr lvl="1"/>
-            <a:r>
-              <a:rPr lang="ko-KR" altLang="en-US" sz="2000" dirty="0"/>
-              <a:t>여러 </a:t>
-            </a:r>
-            <a:r>
-              <a:rPr lang="en-US" altLang="ko-KR" sz="2000" dirty="0"/>
-              <a:t>Condition</a:t>
-            </a:r>
-            <a:r>
-              <a:rPr lang="ko-KR" altLang="en-US" sz="2000" dirty="0"/>
-              <a:t>을 조합해 다 부합하면 </a:t>
-            </a:r>
-            <a:r>
-              <a:rPr lang="en-US" altLang="ko-KR" sz="2000" dirty="0"/>
-              <a:t>Action</a:t>
-            </a:r>
-            <a:r>
-              <a:rPr lang="ko-KR" altLang="en-US" sz="2000" dirty="0"/>
-              <a:t>을 수행</a:t>
-            </a:r>
-            <a:endParaRPr lang="en-US" altLang="ko-KR" sz="2000" dirty="0"/>
+        <p:spPr/>
+        <p:txBody>
+          <a:bodyPr/>
+          <a:lstStyle/>
+          <a:p>
+            <a:endParaRPr lang="ko-KR" altLang="en-US"/>
           </a:p>
         </p:txBody>
       </p:sp>
       <p:pic>
         <p:nvPicPr>
-          <p:cNvPr id="5" name="그림 4">
-            <a:extLst>
-              <a:ext uri="{FF2B5EF4-FFF2-40B4-BE49-F238E27FC236}">
-                <a16:creationId xmlns:a16="http://schemas.microsoft.com/office/drawing/2014/main" id="{1168450F-F8F5-4E04-AB6E-A0DBBCEF2F68}"/>
+          <p:cNvPr id="10" name="그림 9">
+            <a:extLst>
+              <a:ext uri="{FF2B5EF4-FFF2-40B4-BE49-F238E27FC236}">
+                <a16:creationId xmlns:a16="http://schemas.microsoft.com/office/drawing/2014/main" id="{441A3E9F-E1F8-4983-9F23-10F91002982D}"/>
               </a:ext>
             </a:extLst>
           </p:cNvPr>
@@ -5251,242 +5178,69 @@
           <p:nvPr/>
         </p:nvPicPr>
         <p:blipFill>
-          <a:blip r:embed="rId2"/>
+          <a:blip r:embed="rId2">
+            <a:extLst>
+              <a:ext uri="{28A0092B-C50C-407E-A947-70E740481C1C}">
+                <a14:useLocalDpi xmlns:a14="http://schemas.microsoft.com/office/drawing/2010/main" val="0"/>
+              </a:ext>
+            </a:extLst>
+          </a:blip>
           <a:stretch>
             <a:fillRect/>
           </a:stretch>
         </p:blipFill>
         <p:spPr>
           <a:xfrm>
-            <a:off x="7597727" y="1916211"/>
-            <a:ext cx="3756073" cy="4244878"/>
+            <a:off x="1" y="0"/>
+            <a:ext cx="5338122" cy="5726349"/>
           </a:xfrm>
           <a:prstGeom prst="rect">
             <a:avLst/>
           </a:prstGeom>
         </p:spPr>
       </p:pic>
-      <p:sp>
-        <p:nvSpPr>
-          <p:cNvPr id="6" name="내용 개체 틀 2">
-            <a:extLst>
-              <a:ext uri="{FF2B5EF4-FFF2-40B4-BE49-F238E27FC236}">
-                <a16:creationId xmlns:a16="http://schemas.microsoft.com/office/drawing/2014/main" id="{D9FA7950-5CF4-45A8-9CE6-DE850C64A7E0}"/>
-              </a:ext>
-            </a:extLst>
-          </p:cNvPr>
-          <p:cNvSpPr txBox="1">
-            <a:spLocks/>
-          </p:cNvSpPr>
+      <p:pic>
+        <p:nvPicPr>
+          <p:cNvPr id="6" name="그림 5">
+            <a:extLst>
+              <a:ext uri="{FF2B5EF4-FFF2-40B4-BE49-F238E27FC236}">
+                <a16:creationId xmlns:a16="http://schemas.microsoft.com/office/drawing/2014/main" id="{E73709C4-2B6C-469A-85ED-6A7CCFDB1C65}"/>
+              </a:ext>
+            </a:extLst>
+          </p:cNvPr>
+          <p:cNvPicPr>
+            <a:picLocks noChangeAspect="1"/>
+          </p:cNvPicPr>
           <p:nvPr/>
-        </p:nvSpPr>
+        </p:nvPicPr>
+        <p:blipFill>
+          <a:blip r:embed="rId3">
+            <a:extLst>
+              <a:ext uri="{28A0092B-C50C-407E-A947-70E740481C1C}">
+                <a14:useLocalDpi xmlns:a14="http://schemas.microsoft.com/office/drawing/2010/main" val="0"/>
+              </a:ext>
+            </a:extLst>
+          </a:blip>
+          <a:stretch>
+            <a:fillRect/>
+          </a:stretch>
+        </p:blipFill>
         <p:spPr>
           <a:xfrm>
-            <a:off x="647700" y="2949672"/>
-            <a:ext cx="8972550" cy="1479453"/>
+            <a:off x="4784487" y="0"/>
+            <a:ext cx="5411621" cy="6858000"/>
           </a:xfrm>
           <a:prstGeom prst="rect">
             <a:avLst/>
           </a:prstGeom>
         </p:spPr>
-        <p:txBody>
-          <a:bodyPr vert="horz" lIns="91440" tIns="45720" rIns="91440" bIns="45720" rtlCol="0">
-            <a:normAutofit/>
-          </a:bodyPr>
-          <a:lstStyle>
-            <a:lvl1pPr marL="228600" indent="-228600" algn="l" defTabSz="914400" rtl="0" eaLnBrk="1" latinLnBrk="1" hangingPunct="1">
-              <a:lnSpc>
-                <a:spcPct val="90000"/>
-              </a:lnSpc>
-              <a:spcBef>
-                <a:spcPts val="1000"/>
-              </a:spcBef>
-              <a:buFont typeface="Arial" panose="020B0604020202020204" pitchFamily="34" charset="0"/>
-              <a:buChar char="•"/>
-              <a:defRPr sz="2800" kern="1200">
-                <a:solidFill>
-                  <a:schemeClr val="tx1"/>
-                </a:solidFill>
-                <a:latin typeface="+mn-lt"/>
-                <a:ea typeface="+mn-ea"/>
-                <a:cs typeface="+mn-cs"/>
-              </a:defRPr>
-            </a:lvl1pPr>
-            <a:lvl2pPr marL="685800" indent="-228600" algn="l" defTabSz="914400" rtl="0" eaLnBrk="1" latinLnBrk="1" hangingPunct="1">
-              <a:lnSpc>
-                <a:spcPct val="90000"/>
-              </a:lnSpc>
-              <a:spcBef>
-                <a:spcPts val="500"/>
-              </a:spcBef>
-              <a:buFont typeface="Arial" panose="020B0604020202020204" pitchFamily="34" charset="0"/>
-              <a:buChar char="•"/>
-              <a:defRPr sz="2400" kern="1200">
-                <a:solidFill>
-                  <a:schemeClr val="tx1"/>
-                </a:solidFill>
-                <a:latin typeface="+mn-lt"/>
-                <a:ea typeface="+mn-ea"/>
-                <a:cs typeface="+mn-cs"/>
-              </a:defRPr>
-            </a:lvl2pPr>
-            <a:lvl3pPr marL="1143000" indent="-228600" algn="l" defTabSz="914400" rtl="0" eaLnBrk="1" latinLnBrk="1" hangingPunct="1">
-              <a:lnSpc>
-                <a:spcPct val="90000"/>
-              </a:lnSpc>
-              <a:spcBef>
-                <a:spcPts val="500"/>
-              </a:spcBef>
-              <a:buFont typeface="Arial" panose="020B0604020202020204" pitchFamily="34" charset="0"/>
-              <a:buChar char="•"/>
-              <a:defRPr sz="2000" kern="1200">
-                <a:solidFill>
-                  <a:schemeClr val="tx1"/>
-                </a:solidFill>
-                <a:latin typeface="+mn-lt"/>
-                <a:ea typeface="+mn-ea"/>
-                <a:cs typeface="+mn-cs"/>
-              </a:defRPr>
-            </a:lvl3pPr>
-            <a:lvl4pPr marL="1600200" indent="-228600" algn="l" defTabSz="914400" rtl="0" eaLnBrk="1" latinLnBrk="1" hangingPunct="1">
-              <a:lnSpc>
-                <a:spcPct val="90000"/>
-              </a:lnSpc>
-              <a:spcBef>
-                <a:spcPts val="500"/>
-              </a:spcBef>
-              <a:buFont typeface="Arial" panose="020B0604020202020204" pitchFamily="34" charset="0"/>
-              <a:buChar char="•"/>
-              <a:defRPr sz="1800" kern="1200">
-                <a:solidFill>
-                  <a:schemeClr val="tx1"/>
-                </a:solidFill>
-                <a:latin typeface="+mn-lt"/>
-                <a:ea typeface="+mn-ea"/>
-                <a:cs typeface="+mn-cs"/>
-              </a:defRPr>
-            </a:lvl4pPr>
-            <a:lvl5pPr marL="2057400" indent="-228600" algn="l" defTabSz="914400" rtl="0" eaLnBrk="1" latinLnBrk="1" hangingPunct="1">
-              <a:lnSpc>
-                <a:spcPct val="90000"/>
-              </a:lnSpc>
-              <a:spcBef>
-                <a:spcPts val="500"/>
-              </a:spcBef>
-              <a:buFont typeface="Arial" panose="020B0604020202020204" pitchFamily="34" charset="0"/>
-              <a:buChar char="•"/>
-              <a:defRPr sz="1800" kern="1200">
-                <a:solidFill>
-                  <a:schemeClr val="tx1"/>
-                </a:solidFill>
-                <a:latin typeface="+mn-lt"/>
-                <a:ea typeface="+mn-ea"/>
-                <a:cs typeface="+mn-cs"/>
-              </a:defRPr>
-            </a:lvl5pPr>
-            <a:lvl6pPr marL="2514600" indent="-228600" algn="l" defTabSz="914400" rtl="0" eaLnBrk="1" latinLnBrk="1" hangingPunct="1">
-              <a:lnSpc>
-                <a:spcPct val="90000"/>
-              </a:lnSpc>
-              <a:spcBef>
-                <a:spcPts val="500"/>
-              </a:spcBef>
-              <a:buFont typeface="Arial" panose="020B0604020202020204" pitchFamily="34" charset="0"/>
-              <a:buChar char="•"/>
-              <a:defRPr sz="1800" kern="1200">
-                <a:solidFill>
-                  <a:schemeClr val="tx1"/>
-                </a:solidFill>
-                <a:latin typeface="+mn-lt"/>
-                <a:ea typeface="+mn-ea"/>
-                <a:cs typeface="+mn-cs"/>
-              </a:defRPr>
-            </a:lvl6pPr>
-            <a:lvl7pPr marL="2971800" indent="-228600" algn="l" defTabSz="914400" rtl="0" eaLnBrk="1" latinLnBrk="1" hangingPunct="1">
-              <a:lnSpc>
-                <a:spcPct val="90000"/>
-              </a:lnSpc>
-              <a:spcBef>
-                <a:spcPts val="500"/>
-              </a:spcBef>
-              <a:buFont typeface="Arial" panose="020B0604020202020204" pitchFamily="34" charset="0"/>
-              <a:buChar char="•"/>
-              <a:defRPr sz="1800" kern="1200">
-                <a:solidFill>
-                  <a:schemeClr val="tx1"/>
-                </a:solidFill>
-                <a:latin typeface="+mn-lt"/>
-                <a:ea typeface="+mn-ea"/>
-                <a:cs typeface="+mn-cs"/>
-              </a:defRPr>
-            </a:lvl7pPr>
-            <a:lvl8pPr marL="3429000" indent="-228600" algn="l" defTabSz="914400" rtl="0" eaLnBrk="1" latinLnBrk="1" hangingPunct="1">
-              <a:lnSpc>
-                <a:spcPct val="90000"/>
-              </a:lnSpc>
-              <a:spcBef>
-                <a:spcPts val="500"/>
-              </a:spcBef>
-              <a:buFont typeface="Arial" panose="020B0604020202020204" pitchFamily="34" charset="0"/>
-              <a:buChar char="•"/>
-              <a:defRPr sz="1800" kern="1200">
-                <a:solidFill>
-                  <a:schemeClr val="tx1"/>
-                </a:solidFill>
-                <a:latin typeface="+mn-lt"/>
-                <a:ea typeface="+mn-ea"/>
-                <a:cs typeface="+mn-cs"/>
-              </a:defRPr>
-            </a:lvl8pPr>
-            <a:lvl9pPr marL="3886200" indent="-228600" algn="l" defTabSz="914400" rtl="0" eaLnBrk="1" latinLnBrk="1" hangingPunct="1">
-              <a:lnSpc>
-                <a:spcPct val="90000"/>
-              </a:lnSpc>
-              <a:spcBef>
-                <a:spcPts val="500"/>
-              </a:spcBef>
-              <a:buFont typeface="Arial" panose="020B0604020202020204" pitchFamily="34" charset="0"/>
-              <a:buChar char="•"/>
-              <a:defRPr sz="1800" kern="1200">
-                <a:solidFill>
-                  <a:schemeClr val="tx1"/>
-                </a:solidFill>
-                <a:latin typeface="+mn-lt"/>
-                <a:ea typeface="+mn-ea"/>
-                <a:cs typeface="+mn-cs"/>
-              </a:defRPr>
-            </a:lvl9pPr>
-          </a:lstStyle>
-          <a:p>
-            <a:r>
-              <a:rPr lang="en-US" altLang="ko-KR" sz="2400" dirty="0"/>
-              <a:t>Selector</a:t>
-            </a:r>
-          </a:p>
-          <a:p>
-            <a:pPr lvl="1"/>
-            <a:r>
-              <a:rPr lang="ko-KR" altLang="en-US" sz="2000" dirty="0"/>
-              <a:t>자식을 위에서부터 확인</a:t>
-            </a:r>
-            <a:endParaRPr lang="en-US" altLang="ko-KR" sz="1600" dirty="0"/>
-          </a:p>
-          <a:p>
-            <a:pPr lvl="1"/>
-            <a:r>
-              <a:rPr lang="ko-KR" altLang="en-US" sz="2000" dirty="0"/>
-              <a:t>성공하면 아래는 안 봄</a:t>
-            </a:r>
-            <a:endParaRPr lang="en-US" altLang="ko-KR" sz="2800" dirty="0"/>
-          </a:p>
-        </p:txBody>
-      </p:sp>
-      <p:sp>
-        <p:nvSpPr>
-          <p:cNvPr id="8" name="TextBox 7">
-            <a:extLst>
-              <a:ext uri="{FF2B5EF4-FFF2-40B4-BE49-F238E27FC236}">
-                <a16:creationId xmlns:a16="http://schemas.microsoft.com/office/drawing/2014/main" id="{CC02D049-C70A-4DC6-AA3B-6E45C62ED628}"/>
+      </p:pic>
+      <p:sp>
+        <p:nvSpPr>
+          <p:cNvPr id="13" name="TextBox 12">
+            <a:extLst>
+              <a:ext uri="{FF2B5EF4-FFF2-40B4-BE49-F238E27FC236}">
+                <a16:creationId xmlns:a16="http://schemas.microsoft.com/office/drawing/2014/main" id="{B493B938-E885-464E-9CF6-CE6790C3DF6C}"/>
               </a:ext>
             </a:extLst>
           </p:cNvPr>
@@ -5495,8 +5249,8 @@
         </p:nvSpPr>
         <p:spPr>
           <a:xfrm>
-            <a:off x="647700" y="4874994"/>
-            <a:ext cx="6096000" cy="646331"/>
+            <a:off x="8612221" y="1690688"/>
+            <a:ext cx="3748391" cy="1983685"/>
           </a:xfrm>
           <a:prstGeom prst="rect">
             <a:avLst/>
@@ -5509,44 +5263,106 @@
           </a:bodyPr>
           <a:lstStyle/>
           <a:p>
-            <a:r>
-              <a:rPr lang="ko-KR" altLang="en-US" dirty="0"/>
-              <a:t>체력이 낮으면 공격 가능해도 도망간다.</a:t>
-            </a:r>
-          </a:p>
-          <a:p>
-            <a:r>
-              <a:rPr lang="ko-KR" altLang="en-US" dirty="0"/>
-              <a:t>왜냐하면 </a:t>
-            </a:r>
-            <a:r>
-              <a:rPr lang="ko-KR" altLang="en-US" dirty="0" err="1"/>
-              <a:t>Flee가</a:t>
-            </a:r>
-            <a:r>
-              <a:rPr lang="ko-KR" altLang="en-US" dirty="0"/>
-              <a:t> </a:t>
-            </a:r>
-            <a:r>
-              <a:rPr lang="ko-KR" altLang="en-US" dirty="0" err="1"/>
-              <a:t>Attack보다</a:t>
-            </a:r>
-            <a:r>
-              <a:rPr lang="ko-KR" altLang="en-US" dirty="0"/>
-              <a:t> 위에 있기 때문이다.    </a:t>
-            </a:r>
-            <a:r>
-              <a:rPr lang="en-US" altLang="ko-KR" dirty="0"/>
-              <a:t>-&gt;</a:t>
-            </a:r>
-            <a:endParaRPr lang="ko-KR" altLang="en-US" dirty="0"/>
+            <a:pPr>
+              <a:lnSpc>
+                <a:spcPct val="200000"/>
+              </a:lnSpc>
+            </a:pPr>
+            <a:r>
+              <a:rPr lang="ko-KR" altLang="en-US" sz="1600" dirty="0"/>
+              <a:t>매 프레임 </a:t>
+            </a:r>
+            <a:r>
+              <a:rPr lang="ko-KR" altLang="en-US" sz="1600" dirty="0" err="1"/>
+              <a:t>Update</a:t>
+            </a:r>
+            <a:r>
+              <a:rPr lang="ko-KR" altLang="en-US" sz="1600" dirty="0"/>
+              <a:t>() </a:t>
+            </a:r>
+            <a:endParaRPr lang="en-US" altLang="ko-KR" sz="1600" dirty="0"/>
+          </a:p>
+          <a:p>
+            <a:pPr>
+              <a:lnSpc>
+                <a:spcPct val="200000"/>
+              </a:lnSpc>
+            </a:pPr>
+            <a:r>
+              <a:rPr lang="ko-KR" altLang="en-US" sz="1600" dirty="0"/>
+              <a:t> → </a:t>
+            </a:r>
+            <a:r>
+              <a:rPr lang="ko-KR" altLang="en-US" sz="1600" dirty="0" err="1"/>
+              <a:t>root</a:t>
+            </a:r>
+            <a:r>
+              <a:rPr lang="ko-KR" altLang="en-US" sz="1600" dirty="0"/>
+              <a:t>(</a:t>
+            </a:r>
+            <a:r>
+              <a:rPr lang="ko-KR" altLang="en-US" sz="1600" dirty="0" err="1"/>
+              <a:t>Selector</a:t>
+            </a:r>
+            <a:r>
+              <a:rPr lang="ko-KR" altLang="en-US" sz="1600" dirty="0"/>
+              <a:t>).</a:t>
+            </a:r>
+            <a:r>
+              <a:rPr lang="ko-KR" altLang="en-US" sz="1600" dirty="0" err="1"/>
+              <a:t>Tick</a:t>
+            </a:r>
+            <a:r>
+              <a:rPr lang="ko-KR" altLang="en-US" sz="1600" dirty="0"/>
+              <a:t>()  </a:t>
+            </a:r>
+            <a:endParaRPr lang="en-US" altLang="ko-KR" sz="1600" dirty="0"/>
+          </a:p>
+          <a:p>
+            <a:pPr>
+              <a:lnSpc>
+                <a:spcPct val="200000"/>
+              </a:lnSpc>
+            </a:pPr>
+            <a:r>
+              <a:rPr lang="ko-KR" altLang="en-US" sz="1600" dirty="0"/>
+              <a:t>→ 위쪽 가지부터 </a:t>
+            </a:r>
+            <a:r>
+              <a:rPr lang="ko-KR" altLang="en-US" sz="1600" dirty="0" err="1"/>
+              <a:t>Sequence.Tick</a:t>
+            </a:r>
+            <a:r>
+              <a:rPr lang="ko-KR" altLang="en-US" sz="1600" dirty="0"/>
+              <a:t>()  </a:t>
+            </a:r>
+            <a:endParaRPr lang="en-US" altLang="ko-KR" sz="1600" dirty="0"/>
+          </a:p>
+          <a:p>
+            <a:pPr>
+              <a:lnSpc>
+                <a:spcPct val="200000"/>
+              </a:lnSpc>
+            </a:pPr>
+            <a:r>
+              <a:rPr lang="ko-KR" altLang="en-US" sz="1600" dirty="0"/>
+              <a:t>→ 조건이 참이면 </a:t>
+            </a:r>
+            <a:r>
+              <a:rPr lang="ko-KR" altLang="en-US" sz="1600" dirty="0" err="1"/>
+              <a:t>Action.Tick</a:t>
+            </a:r>
+            <a:r>
+              <a:rPr lang="ko-KR" altLang="en-US" sz="1600" dirty="0"/>
+              <a:t>()</a:t>
+            </a:r>
           </a:p>
         </p:txBody>
       </p:sp>
     </p:spTree>
     <p:extLst>
       <p:ext uri="{BB962C8B-B14F-4D97-AF65-F5344CB8AC3E}">
-        <p14:creationId xmlns:p14="http://schemas.microsoft.com/office/powerpoint/2010/main" val="917153459"/>
+        <p14:creationId xmlns:p14="http://schemas.microsoft.com/office/powerpoint/2010/main" val="2366107332"/>
       </p:ext>
     </p:extLst>
   </p:cSld>
@@ -5591,8 +5407,8 @@
         </p:nvSpPr>
         <p:spPr>
           <a:xfrm>
-            <a:off x="739706" y="314180"/>
-            <a:ext cx="10515600" cy="733714"/>
+            <a:off x="838200" y="69850"/>
+            <a:ext cx="10515600" cy="1325563"/>
           </a:xfrm>
         </p:spPr>
         <p:txBody>
@@ -5602,19 +5418,22 @@
           <a:lstStyle/>
           <a:p>
             <a:r>
-              <a:rPr lang="ko-KR" altLang="en-US" sz="4000"/>
-              <a:t>코드는 이런 느낌</a:t>
-            </a:r>
-            <a:endParaRPr lang="ko-KR" altLang="en-US" sz="4000" dirty="0"/>
-          </a:p>
-        </p:txBody>
-      </p:sp>
-      <p:sp>
-        <p:nvSpPr>
-          <p:cNvPr id="7" name="내용 개체 틀 6">
-            <a:extLst>
-              <a:ext uri="{FF2B5EF4-FFF2-40B4-BE49-F238E27FC236}">
-                <a16:creationId xmlns:a16="http://schemas.microsoft.com/office/drawing/2014/main" id="{4D0E45F6-2F98-403E-8900-EE9AB7520860}"/>
+              <a:rPr lang="en-US" altLang="ko-KR" sz="4000" dirty="0"/>
+              <a:t>Condition </a:t>
+            </a:r>
+            <a:r>
+              <a:rPr lang="ko-KR" altLang="en-US" sz="4000" dirty="0"/>
+              <a:t>재사용 방식</a:t>
+            </a:r>
+          </a:p>
+        </p:txBody>
+      </p:sp>
+      <p:sp>
+        <p:nvSpPr>
+          <p:cNvPr id="3" name="내용 개체 틀 2">
+            <a:extLst>
+              <a:ext uri="{FF2B5EF4-FFF2-40B4-BE49-F238E27FC236}">
+                <a16:creationId xmlns:a16="http://schemas.microsoft.com/office/drawing/2014/main" id="{578179D0-6416-4939-9907-B677FF860F6B}"/>
               </a:ext>
             </a:extLst>
           </p:cNvPr>
@@ -5625,21 +5444,40 @@
             <p:ph idx="1"/>
           </p:nvPr>
         </p:nvSpPr>
-        <p:spPr/>
-        <p:txBody>
-          <a:bodyPr/>
-          <a:lstStyle/>
-          <a:p>
-            <a:endParaRPr lang="ko-KR" altLang="en-US" dirty="0"/>
+        <p:spPr>
+          <a:xfrm>
+            <a:off x="647700" y="1395413"/>
+            <a:ext cx="8972550" cy="1033462"/>
+          </a:xfrm>
+        </p:spPr>
+        <p:txBody>
+          <a:bodyPr>
+            <a:normAutofit/>
+          </a:bodyPr>
+          <a:lstStyle/>
+          <a:p>
+            <a:r>
+              <a:rPr lang="ko-KR" altLang="en-US" sz="2400" dirty="0"/>
+              <a:t>객체를 공유하지 않고</a:t>
+            </a:r>
+            <a:r>
+              <a:rPr lang="en-US" altLang="ko-KR" sz="2400" dirty="0"/>
+              <a:t>, </a:t>
+            </a:r>
+            <a:r>
+              <a:rPr lang="ko-KR" altLang="en-US" sz="2400" dirty="0"/>
+              <a:t>로직을 재사용</a:t>
+            </a:r>
+            <a:endParaRPr lang="en-US" altLang="ko-KR" sz="2000" dirty="0"/>
           </a:p>
         </p:txBody>
       </p:sp>
       <p:pic>
         <p:nvPicPr>
-          <p:cNvPr id="12" name="그림 11">
-            <a:extLst>
-              <a:ext uri="{FF2B5EF4-FFF2-40B4-BE49-F238E27FC236}">
-                <a16:creationId xmlns:a16="http://schemas.microsoft.com/office/drawing/2014/main" id="{B8AD8367-6C4E-4D54-86C6-C1F77465AEA3}"/>
+          <p:cNvPr id="7" name="그림 6">
+            <a:extLst>
+              <a:ext uri="{FF2B5EF4-FFF2-40B4-BE49-F238E27FC236}">
+                <a16:creationId xmlns:a16="http://schemas.microsoft.com/office/drawing/2014/main" id="{E7DA1F63-9090-47EE-9D7A-9645A29475F7}"/>
               </a:ext>
             </a:extLst>
           </p:cNvPr>
@@ -5656,8 +5494,8 @@
         </p:blipFill>
         <p:spPr>
           <a:xfrm>
-            <a:off x="205986" y="1318472"/>
-            <a:ext cx="5280414" cy="2328862"/>
+            <a:off x="647700" y="2138196"/>
+            <a:ext cx="4851465" cy="1727222"/>
           </a:xfrm>
           <a:prstGeom prst="rect">
             <a:avLst/>
@@ -5666,10 +5504,10 @@
       </p:pic>
       <p:pic>
         <p:nvPicPr>
-          <p:cNvPr id="14" name="그림 13">
-            <a:extLst>
-              <a:ext uri="{FF2B5EF4-FFF2-40B4-BE49-F238E27FC236}">
-                <a16:creationId xmlns:a16="http://schemas.microsoft.com/office/drawing/2014/main" id="{06A45364-402A-4B49-81B0-AA3D19F55B4E}"/>
+          <p:cNvPr id="10" name="그림 9">
+            <a:extLst>
+              <a:ext uri="{FF2B5EF4-FFF2-40B4-BE49-F238E27FC236}">
+                <a16:creationId xmlns:a16="http://schemas.microsoft.com/office/drawing/2014/main" id="{0AB95DBD-915C-496E-8F90-C6D051E54B57}"/>
               </a:ext>
             </a:extLst>
           </p:cNvPr>
@@ -5686,8 +5524,8 @@
         </p:blipFill>
         <p:spPr>
           <a:xfrm>
-            <a:off x="5612923" y="1318472"/>
-            <a:ext cx="6373091" cy="3805420"/>
+            <a:off x="647700" y="3998569"/>
+            <a:ext cx="7110845" cy="2329834"/>
           </a:xfrm>
           <a:prstGeom prst="rect">
             <a:avLst/>
@@ -5696,10 +5534,10 @@
       </p:pic>
       <p:sp>
         <p:nvSpPr>
-          <p:cNvPr id="16" name="TextBox 15">
-            <a:extLst>
-              <a:ext uri="{FF2B5EF4-FFF2-40B4-BE49-F238E27FC236}">
-                <a16:creationId xmlns:a16="http://schemas.microsoft.com/office/drawing/2014/main" id="{80EBD9DB-EC32-44BB-BC85-796CF3CE8B45}"/>
+          <p:cNvPr id="12" name="TextBox 11">
+            <a:extLst>
+              <a:ext uri="{FF2B5EF4-FFF2-40B4-BE49-F238E27FC236}">
+                <a16:creationId xmlns:a16="http://schemas.microsoft.com/office/drawing/2014/main" id="{8B82D002-2B55-44BC-988B-FC68F80679A8}"/>
               </a:ext>
             </a:extLst>
           </p:cNvPr>
@@ -5708,8 +5546,8 @@
         </p:nvSpPr>
         <p:spPr>
           <a:xfrm>
-            <a:off x="484909" y="4154487"/>
-            <a:ext cx="6096000" cy="2308324"/>
+            <a:off x="5778975" y="2562026"/>
+            <a:ext cx="6096000" cy="748603"/>
           </a:xfrm>
           <a:prstGeom prst="rect">
             <a:avLst/>
@@ -5722,73 +5560,29 @@
           </a:bodyPr>
           <a:lstStyle/>
           <a:p>
-            <a:r>
-              <a:rPr lang="ko-KR" altLang="en-US" dirty="0" err="1"/>
-              <a:t>SelectorNode</a:t>
-            </a:r>
-            <a:r>
-              <a:rPr lang="ko-KR" altLang="en-US" dirty="0"/>
-              <a:t>, </a:t>
-            </a:r>
-            <a:r>
-              <a:rPr lang="ko-KR" altLang="en-US" dirty="0" err="1"/>
-              <a:t>SequenceNode</a:t>
-            </a:r>
-            <a:r>
-              <a:rPr lang="ko-KR" altLang="en-US" dirty="0"/>
-              <a:t>:</a:t>
-            </a:r>
-          </a:p>
-          <a:p>
-            <a:r>
-              <a:rPr lang="ko-KR" altLang="en-US" dirty="0"/>
-              <a:t>자식을 여러 개 가진다.</a:t>
-            </a:r>
-          </a:p>
-          <a:p>
-            <a:endParaRPr lang="ko-KR" altLang="en-US" dirty="0"/>
-          </a:p>
-          <a:p>
+            <a:pPr>
+              <a:lnSpc>
+                <a:spcPct val="125000"/>
+              </a:lnSpc>
+            </a:pPr>
             <a:r>
               <a:rPr lang="ko-KR" altLang="en-US" dirty="0" err="1"/>
               <a:t>ConditionNode</a:t>
             </a:r>
             <a:r>
               <a:rPr lang="ko-KR" altLang="en-US" dirty="0"/>
-              <a:t>, </a:t>
-            </a:r>
-            <a:r>
-              <a:rPr lang="ko-KR" altLang="en-US" dirty="0" err="1"/>
-              <a:t>ActionNode</a:t>
-            </a:r>
+              <a:t> 객체는 각각 따로 만든다.</a:t>
+            </a:r>
+          </a:p>
+          <a:p>
+            <a:pPr>
+              <a:lnSpc>
+                <a:spcPct val="125000"/>
+              </a:lnSpc>
+            </a:pPr>
             <a:r>
               <a:rPr lang="ko-KR" altLang="en-US" dirty="0"/>
-              <a:t>:</a:t>
-            </a:r>
-          </a:p>
-          <a:p>
-            <a:r>
-              <a:rPr lang="ko-KR" altLang="en-US" dirty="0"/>
-              <a:t>보통 자식이 없다.</a:t>
-            </a:r>
-          </a:p>
-          <a:p>
-            <a:endParaRPr lang="ko-KR" altLang="en-US" dirty="0"/>
-          </a:p>
-          <a:p>
-            <a:r>
-              <a:rPr lang="ko-KR" altLang="en-US" dirty="0" err="1"/>
-              <a:t>unique_ptr</a:t>
-            </a:r>
-            <a:r>
-              <a:rPr lang="ko-KR" altLang="en-US" dirty="0"/>
-              <a:t>:</a:t>
-            </a:r>
-          </a:p>
-          <a:p>
-            <a:r>
-              <a:rPr lang="ko-KR" altLang="en-US" dirty="0"/>
-              <a:t>부모 노드가 자식 노드를 소유한다.</a:t>
+              <a:t>하지만 내부에서 사용하는 조건 함수는 재사용할 수 있다.</a:t>
             </a:r>
           </a:p>
         </p:txBody>
@@ -5796,7 +5590,7 @@
     </p:spTree>
     <p:extLst>
       <p:ext uri="{BB962C8B-B14F-4D97-AF65-F5344CB8AC3E}">
-        <p14:creationId xmlns:p14="http://schemas.microsoft.com/office/powerpoint/2010/main" val="608002585"/>
+        <p14:creationId xmlns:p14="http://schemas.microsoft.com/office/powerpoint/2010/main" val="2970724066"/>
       </p:ext>
     </p:extLst>
   </p:cSld>
@@ -5841,8 +5635,8 @@
         </p:nvSpPr>
         <p:spPr>
           <a:xfrm>
-            <a:off x="838200" y="69850"/>
-            <a:ext cx="10515600" cy="1325563"/>
+            <a:off x="407894" y="177427"/>
+            <a:ext cx="10515600" cy="898338"/>
           </a:xfrm>
         </p:spPr>
         <p:txBody>
@@ -5852,22 +5646,23 @@
           <a:lstStyle/>
           <a:p>
             <a:r>
+              <a:rPr lang="ko-KR" altLang="en-US" sz="4000" dirty="0"/>
+              <a:t>음</a:t>
+            </a:r>
+            <a:r>
               <a:rPr lang="en-US" altLang="ko-KR" sz="4000" dirty="0"/>
-              <a:t>Condition </a:t>
-            </a:r>
-            <a:r>
-              <a:rPr lang="ko-KR" altLang="en-US" sz="4000" dirty="0"/>
-              <a:t>재사용 방식</a:t>
-            </a:r>
-          </a:p>
-        </p:txBody>
-      </p:sp>
-      <p:sp>
-        <p:nvSpPr>
-          <p:cNvPr id="3" name="내용 개체 틀 2">
-            <a:extLst>
-              <a:ext uri="{FF2B5EF4-FFF2-40B4-BE49-F238E27FC236}">
-                <a16:creationId xmlns:a16="http://schemas.microsoft.com/office/drawing/2014/main" id="{578179D0-6416-4939-9907-B677FF860F6B}"/>
+              <a:t>.</a:t>
+            </a:r>
+            <a:endParaRPr lang="ko-KR" altLang="en-US" sz="4000" dirty="0"/>
+          </a:p>
+        </p:txBody>
+      </p:sp>
+      <p:sp>
+        <p:nvSpPr>
+          <p:cNvPr id="5" name="내용 개체 틀 4">
+            <a:extLst>
+              <a:ext uri="{FF2B5EF4-FFF2-40B4-BE49-F238E27FC236}">
+                <a16:creationId xmlns:a16="http://schemas.microsoft.com/office/drawing/2014/main" id="{DFAB1F94-D79C-49AB-BC8A-FBFC879B3EEB}"/>
               </a:ext>
             </a:extLst>
           </p:cNvPr>
@@ -5880,117 +5675,13 @@
         </p:nvSpPr>
         <p:spPr>
           <a:xfrm>
-            <a:off x="647700" y="1395413"/>
-            <a:ext cx="8972550" cy="1033462"/>
+            <a:off x="497540" y="1201271"/>
+            <a:ext cx="11188621" cy="5095767"/>
           </a:xfrm>
         </p:spPr>
         <p:txBody>
           <a:bodyPr>
             <a:normAutofit/>
-          </a:bodyPr>
-          <a:lstStyle/>
-          <a:p>
-            <a:r>
-              <a:rPr lang="ko-KR" altLang="en-US" sz="2400" dirty="0"/>
-              <a:t>객체를 공유하지 않고</a:t>
-            </a:r>
-            <a:r>
-              <a:rPr lang="en-US" altLang="ko-KR" sz="2400" dirty="0"/>
-              <a:t>, </a:t>
-            </a:r>
-            <a:r>
-              <a:rPr lang="ko-KR" altLang="en-US" sz="2400" dirty="0"/>
-              <a:t>로직을 재사용</a:t>
-            </a:r>
-            <a:endParaRPr lang="en-US" altLang="ko-KR" sz="2000" dirty="0"/>
-          </a:p>
-        </p:txBody>
-      </p:sp>
-      <p:pic>
-        <p:nvPicPr>
-          <p:cNvPr id="7" name="그림 6">
-            <a:extLst>
-              <a:ext uri="{FF2B5EF4-FFF2-40B4-BE49-F238E27FC236}">
-                <a16:creationId xmlns:a16="http://schemas.microsoft.com/office/drawing/2014/main" id="{E7DA1F63-9090-47EE-9D7A-9645A29475F7}"/>
-              </a:ext>
-            </a:extLst>
-          </p:cNvPr>
-          <p:cNvPicPr>
-            <a:picLocks noChangeAspect="1"/>
-          </p:cNvPicPr>
-          <p:nvPr/>
-        </p:nvPicPr>
-        <p:blipFill>
-          <a:blip r:embed="rId2"/>
-          <a:stretch>
-            <a:fillRect/>
-          </a:stretch>
-        </p:blipFill>
-        <p:spPr>
-          <a:xfrm>
-            <a:off x="647700" y="2138196"/>
-            <a:ext cx="4851465" cy="1727222"/>
-          </a:xfrm>
-          <a:prstGeom prst="rect">
-            <a:avLst/>
-          </a:prstGeom>
-        </p:spPr>
-      </p:pic>
-      <p:pic>
-        <p:nvPicPr>
-          <p:cNvPr id="10" name="그림 9">
-            <a:extLst>
-              <a:ext uri="{FF2B5EF4-FFF2-40B4-BE49-F238E27FC236}">
-                <a16:creationId xmlns:a16="http://schemas.microsoft.com/office/drawing/2014/main" id="{0AB95DBD-915C-496E-8F90-C6D051E54B57}"/>
-              </a:ext>
-            </a:extLst>
-          </p:cNvPr>
-          <p:cNvPicPr>
-            <a:picLocks noChangeAspect="1"/>
-          </p:cNvPicPr>
-          <p:nvPr/>
-        </p:nvPicPr>
-        <p:blipFill>
-          <a:blip r:embed="rId3"/>
-          <a:stretch>
-            <a:fillRect/>
-          </a:stretch>
-        </p:blipFill>
-        <p:spPr>
-          <a:xfrm>
-            <a:off x="647700" y="3998569"/>
-            <a:ext cx="7110845" cy="2329834"/>
-          </a:xfrm>
-          <a:prstGeom prst="rect">
-            <a:avLst/>
-          </a:prstGeom>
-        </p:spPr>
-      </p:pic>
-      <p:sp>
-        <p:nvSpPr>
-          <p:cNvPr id="12" name="TextBox 11">
-            <a:extLst>
-              <a:ext uri="{FF2B5EF4-FFF2-40B4-BE49-F238E27FC236}">
-                <a16:creationId xmlns:a16="http://schemas.microsoft.com/office/drawing/2014/main" id="{8B82D002-2B55-44BC-988B-FC68F80679A8}"/>
-              </a:ext>
-            </a:extLst>
-          </p:cNvPr>
-          <p:cNvSpPr txBox="1"/>
-          <p:nvPr/>
-        </p:nvSpPr>
-        <p:spPr>
-          <a:xfrm>
-            <a:off x="5778975" y="2562026"/>
-            <a:ext cx="6096000" cy="748603"/>
-          </a:xfrm>
-          <a:prstGeom prst="rect">
-            <a:avLst/>
-          </a:prstGeom>
-          <a:noFill/>
-        </p:spPr>
-        <p:txBody>
-          <a:bodyPr wrap="square">
-            <a:spAutoFit/>
           </a:bodyPr>
           <a:lstStyle/>
           <a:p>
@@ -6000,12 +5691,12 @@
               </a:lnSpc>
             </a:pPr>
             <a:r>
-              <a:rPr lang="ko-KR" altLang="en-US" dirty="0" err="1"/>
-              <a:t>ConditionNode</a:t>
-            </a:r>
-            <a:r>
-              <a:rPr lang="ko-KR" altLang="en-US" dirty="0"/>
-              <a:t> 객체는 각각 따로 만든다.</a:t>
+              <a:rPr lang="ko-KR" altLang="en-US" sz="1600" dirty="0"/>
+              <a:t>결론적으로 웬만한 캐릭터 행동은 </a:t>
+            </a:r>
+            <a:r>
+              <a:rPr lang="en-US" altLang="ko-KR" sz="1600" dirty="0"/>
+              <a:t>FSM</a:t>
             </a:r>
           </a:p>
           <a:p>
@@ -6014,9 +5705,297 @@
                 <a:spcPct val="125000"/>
               </a:lnSpc>
             </a:pPr>
-            <a:r>
-              <a:rPr lang="ko-KR" altLang="en-US" dirty="0"/>
-              <a:t>하지만 내부에서 사용하는 조건 함수는 재사용할 수 있다.</a:t>
+            <a:endParaRPr lang="en-US" altLang="ko-KR" sz="1600" dirty="0"/>
+          </a:p>
+          <a:p>
+            <a:pPr>
+              <a:lnSpc>
+                <a:spcPct val="125000"/>
+              </a:lnSpc>
+            </a:pPr>
+            <a:r>
+              <a:rPr lang="ko-KR" altLang="en-US" sz="1600" dirty="0"/>
+              <a:t>예시로 들었던 </a:t>
+            </a:r>
+            <a:r>
+              <a:rPr lang="en-US" altLang="ko-KR" sz="1600" dirty="0"/>
+              <a:t>Skeleton</a:t>
+            </a:r>
+            <a:r>
+              <a:rPr lang="ko-KR" altLang="en-US" sz="1600" dirty="0"/>
+              <a:t>처럼</a:t>
+            </a:r>
+            <a:r>
+              <a:rPr lang="en-US" altLang="ko-KR" sz="1600" dirty="0"/>
+              <a:t>, Idle</a:t>
+            </a:r>
+            <a:r>
+              <a:rPr lang="ko-KR" altLang="en-US" sz="1600" dirty="0"/>
+              <a:t>에서 플레이어가 가까워지면 </a:t>
+            </a:r>
+            <a:r>
+              <a:rPr lang="en-US" altLang="ko-KR" sz="1600" dirty="0"/>
+              <a:t>Walk</a:t>
+            </a:r>
+            <a:r>
+              <a:rPr lang="ko-KR" altLang="en-US" sz="1600" dirty="0"/>
+              <a:t>로</a:t>
+            </a:r>
+            <a:r>
+              <a:rPr lang="en-US" altLang="ko-KR" sz="1600" dirty="0"/>
+              <a:t>, </a:t>
+            </a:r>
+            <a:r>
+              <a:rPr lang="ko-KR" altLang="en-US" sz="1600" dirty="0"/>
+              <a:t>사거리에 들어오면 </a:t>
+            </a:r>
+            <a:r>
+              <a:rPr lang="en-US" altLang="ko-KR" sz="1600" dirty="0" err="1"/>
+              <a:t>BowAction</a:t>
+            </a:r>
+            <a:r>
+              <a:rPr lang="ko-KR" altLang="en-US" sz="1600" dirty="0"/>
+              <a:t>으로 전환하고</a:t>
+            </a:r>
+            <a:r>
+              <a:rPr lang="en-US" altLang="ko-KR" sz="1600" dirty="0"/>
+              <a:t>, </a:t>
+            </a:r>
+            <a:r>
+              <a:rPr lang="ko-KR" altLang="en-US" sz="1600" dirty="0"/>
+              <a:t>공격을 받으면 </a:t>
+            </a:r>
+            <a:r>
+              <a:rPr lang="en-US" altLang="ko-KR" sz="1600" dirty="0" err="1"/>
+              <a:t>GetHit</a:t>
+            </a:r>
+            <a:r>
+              <a:rPr lang="ko-KR" altLang="en-US" sz="1600" dirty="0"/>
+              <a:t>으로 넘어가는 흐름은 </a:t>
+            </a:r>
+            <a:r>
+              <a:rPr lang="ko-KR" altLang="en-US" sz="1600" b="1" dirty="0"/>
+              <a:t>현재 상태에서 다음 상태를 정하는 방식</a:t>
+            </a:r>
+            <a:r>
+              <a:rPr lang="ko-KR" altLang="en-US" sz="1600" dirty="0"/>
+              <a:t>으로 충분히 설명할 수 있는 거 </a:t>
+            </a:r>
+            <a:r>
+              <a:rPr lang="ko-KR" altLang="en-US" sz="1600" dirty="0" err="1"/>
+              <a:t>가타유</a:t>
+            </a:r>
+            <a:r>
+              <a:rPr lang="en-US" altLang="ko-KR" sz="1600" dirty="0"/>
+              <a:t>. </a:t>
+            </a:r>
+            <a:r>
+              <a:rPr lang="ko-KR" altLang="en-US" sz="1600" dirty="0"/>
+              <a:t>지금 프로젝트의 플레이어도 </a:t>
+            </a:r>
+            <a:r>
+              <a:rPr lang="en-US" altLang="ko-KR" sz="1600" dirty="0"/>
+              <a:t>Dead, </a:t>
+            </a:r>
+            <a:r>
+              <a:rPr lang="en-US" altLang="ko-KR" sz="1600" dirty="0" err="1"/>
+              <a:t>HitStun</a:t>
+            </a:r>
+            <a:r>
+              <a:rPr lang="en-US" altLang="ko-KR" sz="1600" dirty="0"/>
+              <a:t>, Dash, Attack</a:t>
+            </a:r>
+            <a:r>
+              <a:rPr lang="ko-KR" altLang="en-US" sz="1600" dirty="0"/>
+              <a:t>처럼 행동 수가 적고 전환 규칙이 뚜렷해서 </a:t>
+            </a:r>
+            <a:r>
+              <a:rPr lang="en-US" altLang="ko-KR" sz="1600" dirty="0"/>
+              <a:t>FSM</a:t>
+            </a:r>
+            <a:r>
+              <a:rPr lang="ko-KR" altLang="en-US" sz="1600" dirty="0"/>
+              <a:t>으로 구현할 수 있습니다</a:t>
+            </a:r>
+            <a:r>
+              <a:rPr lang="en-US" altLang="ko-KR" sz="1600" dirty="0"/>
+              <a:t>.</a:t>
+            </a:r>
+          </a:p>
+          <a:p>
+            <a:pPr marL="0" indent="0">
+              <a:lnSpc>
+                <a:spcPct val="125000"/>
+              </a:lnSpc>
+              <a:buNone/>
+            </a:pPr>
+            <a:endParaRPr lang="en-US" altLang="ko-KR" sz="1600" dirty="0"/>
+          </a:p>
+          <a:p>
+            <a:pPr>
+              <a:lnSpc>
+                <a:spcPct val="125000"/>
+              </a:lnSpc>
+            </a:pPr>
+            <a:r>
+              <a:rPr lang="en-US" altLang="ko-KR" sz="1600" b="1" dirty="0"/>
+              <a:t>BT</a:t>
+            </a:r>
+            <a:r>
+              <a:rPr lang="ko-KR" altLang="en-US" sz="1600" b="1" dirty="0"/>
+              <a:t>는 </a:t>
+            </a:r>
+            <a:r>
+              <a:rPr lang="en-US" altLang="ko-KR" sz="1600" b="1" dirty="0"/>
+              <a:t>AI</a:t>
+            </a:r>
+            <a:r>
+              <a:rPr lang="ko-KR" altLang="en-US" sz="1600" b="1" dirty="0"/>
+              <a:t>의 판단 과정 자체가 복잡해질 때 고려</a:t>
+            </a:r>
+            <a:endParaRPr lang="en-US" altLang="ko-KR" sz="1600" b="1" dirty="0"/>
+          </a:p>
+          <a:p>
+            <a:pPr>
+              <a:lnSpc>
+                <a:spcPct val="125000"/>
+              </a:lnSpc>
+            </a:pPr>
+            <a:r>
+              <a:rPr lang="en-US" altLang="ko-KR" sz="1600" dirty="0"/>
+              <a:t>BT</a:t>
+            </a:r>
+            <a:r>
+              <a:rPr lang="ko-KR" altLang="en-US" sz="1600" dirty="0"/>
+              <a:t>를 고려하는 시점은 상태 수가 늘어날 때가 아니라</a:t>
+            </a:r>
+            <a:r>
+              <a:rPr lang="en-US" altLang="ko-KR" sz="1600" dirty="0"/>
+              <a:t>, </a:t>
+            </a:r>
+            <a:r>
+              <a:rPr lang="ko-KR" altLang="en-US" sz="1600" b="1" dirty="0"/>
+              <a:t>행동이 목표를 달성했는지 실패했는지에 따라 다음 방법을 고르는 과정</a:t>
+            </a:r>
+            <a:r>
+              <a:rPr lang="ko-KR" altLang="en-US" sz="1600" dirty="0"/>
+              <a:t>이 설계의 중심이 될 때</a:t>
+            </a:r>
+            <a:endParaRPr lang="en-US" altLang="ko-KR" sz="1600" dirty="0"/>
+          </a:p>
+          <a:p>
+            <a:pPr>
+              <a:lnSpc>
+                <a:spcPct val="125000"/>
+              </a:lnSpc>
+            </a:pPr>
+            <a:r>
+              <a:rPr lang="en-US" altLang="ko-KR" sz="1600" dirty="0"/>
+              <a:t>Ex) </a:t>
+            </a:r>
+            <a:r>
+              <a:rPr lang="ko-KR" altLang="en-US" sz="1600" dirty="0"/>
+              <a:t>스켈레톤</a:t>
+            </a:r>
+            <a:r>
+              <a:rPr lang="en-US" altLang="ko-KR" sz="1600" dirty="0"/>
+              <a:t>2</a:t>
+            </a:r>
+            <a:r>
+              <a:rPr lang="ko-KR" altLang="en-US" sz="1600" dirty="0"/>
+              <a:t>의 목표가 ‘플레이어를 </a:t>
+            </a:r>
+            <a:r>
+              <a:rPr lang="ko-KR" altLang="en-US" sz="1600" dirty="0" err="1"/>
+              <a:t>공격한다’라면</a:t>
+            </a:r>
+            <a:r>
+              <a:rPr lang="en-US" altLang="ko-KR" sz="1600" dirty="0"/>
+              <a:t>, </a:t>
+            </a:r>
+            <a:r>
+              <a:rPr lang="ko-KR" altLang="en-US" sz="1600" dirty="0"/>
+              <a:t>현재 위치에서 쏠 수 있는지 확인하고</a:t>
+            </a:r>
+            <a:r>
+              <a:rPr lang="en-US" altLang="ko-KR" sz="1600" dirty="0"/>
+              <a:t>, </a:t>
+            </a:r>
+            <a:r>
+              <a:rPr lang="ko-KR" altLang="en-US" sz="1600" dirty="0"/>
+              <a:t>안 되면 엄폐 사격 위치를 찾고</a:t>
+            </a:r>
+            <a:r>
+              <a:rPr lang="en-US" altLang="ko-KR" sz="1600" dirty="0"/>
+              <a:t>, </a:t>
+            </a:r>
+            <a:r>
+              <a:rPr lang="ko-KR" altLang="en-US" sz="1600" dirty="0"/>
+              <a:t>그것도 실패하면 측면 경로를 시도할 수 </a:t>
+            </a:r>
+            <a:r>
+              <a:rPr lang="ko-KR" altLang="en-US" sz="1600" dirty="0" err="1"/>
+              <a:t>있읍니다</a:t>
+            </a:r>
+            <a:r>
+              <a:rPr lang="en-US" altLang="ko-KR" sz="1600" dirty="0"/>
+              <a:t>. </a:t>
+            </a:r>
+            <a:r>
+              <a:rPr lang="ko-KR" altLang="en-US" sz="1600" dirty="0"/>
+              <a:t>이동 도중 위험해지면 상위의 회피 행동이 끼어들고</a:t>
+            </a:r>
+            <a:r>
+              <a:rPr lang="en-US" altLang="ko-KR" sz="1600" dirty="0"/>
+              <a:t>, </a:t>
+            </a:r>
+            <a:r>
+              <a:rPr lang="ko-KR" altLang="en-US" sz="1600" dirty="0"/>
+              <a:t>이후에는 상황을 다시 판단합니다</a:t>
+            </a:r>
+            <a:r>
+              <a:rPr lang="en-US" altLang="ko-KR" sz="1600" dirty="0"/>
+              <a:t>. </a:t>
+            </a:r>
+            <a:r>
+              <a:rPr lang="ko-KR" altLang="en-US" sz="1600" dirty="0"/>
+              <a:t>이런 단계와 대안을 반복해서 조합해야 한다면 </a:t>
+            </a:r>
+            <a:r>
+              <a:rPr lang="en-US" altLang="ko-KR" sz="1600" dirty="0"/>
+              <a:t>BT</a:t>
+            </a:r>
+            <a:r>
+              <a:rPr lang="ko-KR" altLang="en-US" sz="1600" dirty="0"/>
+              <a:t>가 읽고 확장하기 편합니다</a:t>
+            </a:r>
+            <a:r>
+              <a:rPr lang="en-US" altLang="ko-KR" sz="1600" dirty="0"/>
+              <a:t>. </a:t>
+            </a:r>
+            <a:r>
+              <a:rPr lang="ko-KR" altLang="en-US" sz="1600" dirty="0"/>
+              <a:t>반면 이번 </a:t>
+            </a:r>
+            <a:r>
+              <a:rPr lang="ko-KR" altLang="en-US" sz="1600" dirty="0" err="1"/>
+              <a:t>스켈레톤처럼</a:t>
+            </a:r>
+            <a:r>
+              <a:rPr lang="ko-KR" altLang="en-US" sz="1600" dirty="0"/>
+              <a:t> 각 행동에서 어디로 전환할지가 핵심이면 </a:t>
+            </a:r>
+            <a:r>
+              <a:rPr lang="en-US" altLang="ko-KR" sz="1600" dirty="0"/>
+              <a:t>FSM</a:t>
+            </a:r>
+            <a:r>
+              <a:rPr lang="ko-KR" altLang="en-US" sz="1600" dirty="0"/>
+              <a:t>부터 쓰겠습니다</a:t>
+            </a:r>
+            <a:r>
+              <a:rPr lang="en-US" altLang="ko-KR" sz="1600" dirty="0"/>
+              <a:t>.</a:t>
             </a:r>
           </a:p>
         </p:txBody>
@@ -6024,7 +6003,7 @@
     </p:spTree>
     <p:extLst>
       <p:ext uri="{BB962C8B-B14F-4D97-AF65-F5344CB8AC3E}">
-        <p14:creationId xmlns:p14="http://schemas.microsoft.com/office/powerpoint/2010/main" val="2970724066"/>
+        <p14:creationId xmlns:p14="http://schemas.microsoft.com/office/powerpoint/2010/main" val="1438579093"/>
       </p:ext>
     </p:extLst>
   </p:cSld>

</xml_diff>